<commit_message>
feat: add local Next.js and Supabase Phase 1 foundation
</commit_message>
<xml_diff>
--- a/deliverables/week-5-checkpoint/ParcelTrack-Lite-Week-5.pptx
+++ b/deliverables/week-5-checkpoint/ParcelTrack-Lite-Week-5.pptx
@@ -2,24 +2,24 @@
 <file path=ppt/presentation.xml><?xml version="1.0" encoding="utf-8"?>
 <p:presentation xmlns:p="http://schemas.openxmlformats.org/presentationml/2006/main">
   <p:sldMasterIdLst>
-    <p:sldMasterId xmlns:r="http://schemas.openxmlformats.org/officeDocument/2006/relationships" id="2147483648" r:id="Rf6187921be3e4a9c"/>
+    <p:sldMasterId xmlns:r="http://schemas.openxmlformats.org/officeDocument/2006/relationships" id="2147483648" r:id="Raed345a983334c17"/>
   </p:sldMasterIdLst>
   <p:notesMasterIdLst>
-    <p:notesMasterId xmlns:r="http://schemas.openxmlformats.org/officeDocument/2006/relationships" r:id="R32d373bf4929497e"/>
+    <p:notesMasterId xmlns:r="http://schemas.openxmlformats.org/officeDocument/2006/relationships" r:id="R912451aa7f3644fb"/>
   </p:notesMasterIdLst>
   <p:sldIdLst>
-    <p:sldId xmlns:r="http://schemas.openxmlformats.org/officeDocument/2006/relationships" id="256" r:id="R4cc4f69fe8de42d7"/>
-    <p:sldId xmlns:r="http://schemas.openxmlformats.org/officeDocument/2006/relationships" id="257" r:id="R8f229d2026144466"/>
-    <p:sldId xmlns:r="http://schemas.openxmlformats.org/officeDocument/2006/relationships" id="258" r:id="R57e11ccd6ef4471e"/>
-    <p:sldId xmlns:r="http://schemas.openxmlformats.org/officeDocument/2006/relationships" id="259" r:id="R37d6db296ad64cec"/>
-    <p:sldId xmlns:r="http://schemas.openxmlformats.org/officeDocument/2006/relationships" id="260" r:id="Re761af478fdf4ebf"/>
-    <p:sldId xmlns:r="http://schemas.openxmlformats.org/officeDocument/2006/relationships" id="261" r:id="R9bbc917e5993441c"/>
-    <p:sldId xmlns:r="http://schemas.openxmlformats.org/officeDocument/2006/relationships" id="262" r:id="R4733324d53994fa5"/>
-    <p:sldId xmlns:r="http://schemas.openxmlformats.org/officeDocument/2006/relationships" id="263" r:id="R5a44c0f34b574d03"/>
-    <p:sldId xmlns:r="http://schemas.openxmlformats.org/officeDocument/2006/relationships" id="264" r:id="R08054c292a664de0"/>
-    <p:sldId xmlns:r="http://schemas.openxmlformats.org/officeDocument/2006/relationships" id="265" r:id="Rd5afef07b1a546e4"/>
-    <p:sldId xmlns:r="http://schemas.openxmlformats.org/officeDocument/2006/relationships" id="266" r:id="R2212a24f3f774de7"/>
-    <p:sldId xmlns:r="http://schemas.openxmlformats.org/officeDocument/2006/relationships" id="267" r:id="R8ecce7f7b97c4dda"/>
+    <p:sldId xmlns:r="http://schemas.openxmlformats.org/officeDocument/2006/relationships" id="256" r:id="R4a22d73de2c14ccc"/>
+    <p:sldId xmlns:r="http://schemas.openxmlformats.org/officeDocument/2006/relationships" id="257" r:id="R4061a635d688445f"/>
+    <p:sldId xmlns:r="http://schemas.openxmlformats.org/officeDocument/2006/relationships" id="258" r:id="Rb0f98ddac8e847c2"/>
+    <p:sldId xmlns:r="http://schemas.openxmlformats.org/officeDocument/2006/relationships" id="259" r:id="R73c478c9df494afd"/>
+    <p:sldId xmlns:r="http://schemas.openxmlformats.org/officeDocument/2006/relationships" id="260" r:id="R37786873db8949d7"/>
+    <p:sldId xmlns:r="http://schemas.openxmlformats.org/officeDocument/2006/relationships" id="261" r:id="R023fe393070146b3"/>
+    <p:sldId xmlns:r="http://schemas.openxmlformats.org/officeDocument/2006/relationships" id="262" r:id="R3974f01ede6c4c96"/>
+    <p:sldId xmlns:r="http://schemas.openxmlformats.org/officeDocument/2006/relationships" id="263" r:id="R940935cf1efa4b26"/>
+    <p:sldId xmlns:r="http://schemas.openxmlformats.org/officeDocument/2006/relationships" id="264" r:id="R7f01efdac71742b7"/>
+    <p:sldId xmlns:r="http://schemas.openxmlformats.org/officeDocument/2006/relationships" id="265" r:id="R2e0e0d467463401c"/>
+    <p:sldId xmlns:r="http://schemas.openxmlformats.org/officeDocument/2006/relationships" id="266" r:id="Rda5005aaa9c04ba9"/>
+    <p:sldId xmlns:r="http://schemas.openxmlformats.org/officeDocument/2006/relationships" id="267" r:id="R9147606123744052"/>
   </p:sldIdLst>
   <p:sldSz cx="12192000" cy="6858000"/>
   <p:notesSz cx="6858000" cy="9144000"/>
@@ -538,7 +538,7 @@
           </a:p>
           <a:p xmlns:a="http://schemas.openxmlformats.org/drawingml/2006/main">
             <a:r>
-              <a:t>We have confirmed ownership, selected our stack, published the initial ERD and prepared coherent module plans with test cases and handoffs. We now have runnable React interfaces for the checkpoint and a repeatable sample parcel journey. The prototype builds and its six domain tests and nineteen browser smoke checkpoints pass. These are not results for the final backend suite. Current challenges are keeping shared models consistent, obtaining stack acceptance and AWS access, and replacing browser simulations with verified server behaviour. Branch protection has been prepared but its application remains unverified.</a:t>
+              <a:t>We have confirmed ownership, selected our stack, published the initial ERD and prepared coherent module plans with test cases and handoffs. We now have runnable React interfaces for the checkpoint and a repeatable sample parcel journey. The prototype builds and its six domain tests and nineteen browser smoke checkpoints pass. These are not results for the final backend suite. Current challenges are keeping shared models consistent, obtaining stack acceptance and local Supabase setup, and replacing browser simulations with verified server behaviour. Branch protection has been prepared but its application remains unverified.</a:t>
             </a:r>
           </a:p>
           <a:p xmlns:a="http://schemas.openxmlformats.org/drawingml/2006/main">
@@ -618,12 +618,12 @@
           </a:p>
           <a:p xmlns:a="http://schemas.openxmlformats.org/drawingml/2006/main">
             <a:r>
-              <a:t>This is our proposed schedule, not completed work. Week 6 establishes FastAPI, PostgreSQL roles, migrations and the test harness. Week 7 connects real authenticated module slices. Weeks 8 and 9 complete the functions and attempt an early AWS deployment. Weeks 10 through 12 focus on security regression, storage, recovery and the integrated cloud deployment. Week 13 prepares evidence and rehearsal, and Week 14 is final submission. We will confirm the Week 14 calendar date and update this schedule with actual progress. AI agents can assist implementation, while each member reviews, tests and understands their module.</a:t>
+              <a:t>This is the proposed schedule. Week 6 establishes one Next.js application and the full local Supabase Docker stack with application roles, migrations and a test harness. Week 7 connects real authenticated slices. Weeks 8 and 9 complete local functions and test the Next.js production build. Weeks 10 through 12 cover security and recovery, then cloud deployment after local acceptance and a hosting decision. Week 13 prepares evidence and rehearsal. Week 14 is final submission; its calendar date is unconfirmed. Each member implements, tests and explains their own module.</a:t>
             </a:r>
           </a:p>
           <a:p xmlns:a="http://schemas.openxmlformats.org/drawingml/2006/main">
             <a:r>
-              <a:t>Source: team timeline (Week 5 now, Week 14 final); docs/shared/phase-framework.md. Week mapping is a proposed checkpoint schedule.</a:t>
+              <a:t>Source: docs/shared/phase-framework.md and docs/local-development.md. These are proposed milestones, not completed work.</a:t>
             </a:r>
           </a:p>
         </p:txBody>
@@ -858,12 +858,12 @@
           </a:p>
           <a:p xmlns:a="http://schemas.openxmlformats.org/drawingml/2006/main">
             <a:r>
-              <a:t>We selected React for the interfaces, FastAPI for one shared Python backend, and PostgreSQL in Docker. SQLAlchemy and Alembic will support database access and migrations. AWS is our chosen hosting provider, with one EC2 instance running Docker Compose as the current proposal. The database will remain private, behind the application. These backend and cloud components are planned. The source brief names other framework and database combinations, so acceptance of FastAPI and PostgreSQL still needs confirmation.</a:t>
+              <a:t>We changed the future implementation to one full-stack Next.js and TypeScript application so pages and server logic share one project. PostgreSQL and private proof storage will run in the full Supabase Docker stack locally, including its standard services. We will use pg, ordered SQL migrations, shared Zod validation and the existing custom username/session design. The included Supabase Auth is not a second login authority. This is planned work; the demonstrated interface is still the browser-only React prototype. Cloud hosting comes later, after local integration. Lecturer acceptance of Next.js and PostgreSQL is not recorded.</a:t>
             </a:r>
           </a:p>
           <a:p xmlns:a="http://schemas.openxmlformats.org/drawingml/2006/main">
             <a:r>
-              <a:t>Source: docs/shared/decision-register.md D-01 to D-03 and EXT-02/04; source briefing slide 11 and case study section 6.</a:t>
+              <a:t>Source: docs/nextjs-migration.md; docs/local-development.md; docs/shared/system-contract.md; user direction on 22 October 2026.</a:t>
             </a:r>
           </a:p>
         </p:txBody>
@@ -1018,7 +1018,7 @@
           </a:p>
           <a:p xmlns:a="http://schemas.openxmlformats.org/drawingml/2006/main">
             <a:r>
-              <a:t>This is the M1 interface. It uses a regular username and password form, generic failure messages and different landing pages for Sellers, Riders and Admins. Other screens show Seller registration, Rider management and password change. Test credentials are in the presenter guide, not on the product screens. Authentication is still simulated in the browser. Newly entered passwords exist only in page memory and reset on refresh. The final project will connect to FastAPI sessions, Argon2id hashing, CSRF protection and server authorization.</a:t>
+              <a:t>This is the M1 interface. It uses a regular username and password form, generic failure messages and different landing pages for Sellers, Riders and Admins. Other screens show Seller registration, Rider management and password change. Test credentials are in the presenter guide, not on the product screens. Authentication is still simulated in the browser. Newly entered passwords exist only in page memory and reset on refresh. The final project will connect to Next.js server sessions, Argon2id hashing, CSRF protection and server authorization.</a:t>
             </a:r>
           </a:p>
           <a:p xmlns:a="http://schemas.openxmlformats.org/drawingml/2006/main">
@@ -1390,7 +1390,7 @@
           <p:cNvPr id="3" name="Title">
             <a:extLst xmlns:a="http://schemas.openxmlformats.org/drawingml/2006/main">
               <a:ext uri="{FF2B5EF4-FFF2-40B4-BE49-F238E27FC236}">
-                <a16:creationId xmlns:a16="http://schemas.microsoft.com/office/drawing/2014/main" id="{7367D243-98CE-497E-A78E-CFCF3824098F}"/>
+                <a16:creationId xmlns:a16="http://schemas.microsoft.com/office/drawing/2014/main" id="{5FD1425A-4E8F-4531-A843-8DAF14433205}"/>
               </a:ext>
             </a:extLst>
           </p:cNvPr>
@@ -1619,7 +1619,7 @@
           <p:cNvPr id="2" name="Subtitle">
             <a:extLst xmlns:a="http://schemas.openxmlformats.org/drawingml/2006/main">
               <a:ext uri="{FF2B5EF4-FFF2-40B4-BE49-F238E27FC236}">
-                <a16:creationId xmlns:a16="http://schemas.microsoft.com/office/drawing/2014/main" id="{4A1452AF-D9D9-443C-B68E-13A658E340BA}"/>
+                <a16:creationId xmlns:a16="http://schemas.microsoft.com/office/drawing/2014/main" id="{2C39A22D-F88A-446E-8532-A5CCFB9A1AF9}"/>
               </a:ext>
             </a:extLst>
           </p:cNvPr>
@@ -1865,7 +1865,7 @@
           <p:cNvPr id="2" name="Section title">
             <a:extLst xmlns:a="http://schemas.openxmlformats.org/drawingml/2006/main">
               <a:ext uri="{FF2B5EF4-FFF2-40B4-BE49-F238E27FC236}">
-                <a16:creationId xmlns:a16="http://schemas.microsoft.com/office/drawing/2014/main" id="{93ED0859-A4DA-4152-90C8-9A354462D712}"/>
+                <a16:creationId xmlns:a16="http://schemas.microsoft.com/office/drawing/2014/main" id="{38289D4B-8DA2-4010-BD1A-11F28A51F71F}"/>
               </a:ext>
             </a:extLst>
           </p:cNvPr>
@@ -2111,7 +2111,7 @@
           <p:cNvPr id="3" name="Title">
             <a:extLst xmlns:a="http://schemas.openxmlformats.org/drawingml/2006/main">
               <a:ext uri="{FF2B5EF4-FFF2-40B4-BE49-F238E27FC236}">
-                <a16:creationId xmlns:a16="http://schemas.microsoft.com/office/drawing/2014/main" id="{1D78519B-138B-48FE-83F4-E9722660E10D}"/>
+                <a16:creationId xmlns:a16="http://schemas.microsoft.com/office/drawing/2014/main" id="{65CAB60B-A6B5-4E87-B547-541998D0ACDD}"/>
               </a:ext>
             </a:extLst>
           </p:cNvPr>
@@ -2340,7 +2340,7 @@
           <p:cNvPr id="2" name="Body">
             <a:extLst xmlns:a="http://schemas.openxmlformats.org/drawingml/2006/main">
               <a:ext uri="{FF2B5EF4-FFF2-40B4-BE49-F238E27FC236}">
-                <a16:creationId xmlns:a16="http://schemas.microsoft.com/office/drawing/2014/main" id="{1E001114-817E-4B4F-829E-573CFA7FB0E2}"/>
+                <a16:creationId xmlns:a16="http://schemas.microsoft.com/office/drawing/2014/main" id="{DB078BBF-738F-4D54-BFD0-133439AC43D3}"/>
               </a:ext>
             </a:extLst>
           </p:cNvPr>
@@ -2586,7 +2586,7 @@
           <p:cNvPr id="4" name="Title">
             <a:extLst xmlns:a="http://schemas.openxmlformats.org/drawingml/2006/main">
               <a:ext uri="{FF2B5EF4-FFF2-40B4-BE49-F238E27FC236}">
-                <a16:creationId xmlns:a16="http://schemas.microsoft.com/office/drawing/2014/main" id="{05DB9B3C-7B3C-47A0-AC41-29DE74711BB1}"/>
+                <a16:creationId xmlns:a16="http://schemas.microsoft.com/office/drawing/2014/main" id="{5FBB4DFB-7060-435C-92D3-F0EDEAEB2B92}"/>
               </a:ext>
             </a:extLst>
           </p:cNvPr>
@@ -2815,7 +2815,7 @@
           <p:cNvPr id="2" name="Left column">
             <a:extLst xmlns:a="http://schemas.openxmlformats.org/drawingml/2006/main">
               <a:ext uri="{FF2B5EF4-FFF2-40B4-BE49-F238E27FC236}">
-                <a16:creationId xmlns:a16="http://schemas.microsoft.com/office/drawing/2014/main" id="{40B7E3EE-4ADE-4C19-8B2F-6B17C688D023}"/>
+                <a16:creationId xmlns:a16="http://schemas.microsoft.com/office/drawing/2014/main" id="{7EBF76C3-8110-45EE-96E9-616329DD111E}"/>
               </a:ext>
             </a:extLst>
           </p:cNvPr>
@@ -3044,7 +3044,7 @@
           <p:cNvPr id="3" name="Right column">
             <a:extLst xmlns:a="http://schemas.openxmlformats.org/drawingml/2006/main">
               <a:ext uri="{FF2B5EF4-FFF2-40B4-BE49-F238E27FC236}">
-                <a16:creationId xmlns:a16="http://schemas.microsoft.com/office/drawing/2014/main" id="{66B8D9B9-81B7-4445-9275-4FB17D91D2A1}"/>
+                <a16:creationId xmlns:a16="http://schemas.microsoft.com/office/drawing/2014/main" id="{D9E67585-3541-4772-A0BE-9FA0F3C5449A}"/>
               </a:ext>
             </a:extLst>
           </p:cNvPr>
@@ -3290,7 +3290,7 @@
           <p:cNvPr id="3" name="Title">
             <a:extLst xmlns:a="http://schemas.openxmlformats.org/drawingml/2006/main">
               <a:ext uri="{FF2B5EF4-FFF2-40B4-BE49-F238E27FC236}">
-                <a16:creationId xmlns:a16="http://schemas.microsoft.com/office/drawing/2014/main" id="{52D3518A-99A0-4FE9-A023-869CBB7669E1}"/>
+                <a16:creationId xmlns:a16="http://schemas.microsoft.com/office/drawing/2014/main" id="{EAEB74B4-4633-47FB-8F3C-847747371244}"/>
               </a:ext>
             </a:extLst>
           </p:cNvPr>
@@ -3519,7 +3519,7 @@
           <p:cNvPr id="2" name="Left column">
             <a:extLst xmlns:a="http://schemas.openxmlformats.org/drawingml/2006/main">
               <a:ext uri="{FF2B5EF4-FFF2-40B4-BE49-F238E27FC236}">
-                <a16:creationId xmlns:a16="http://schemas.microsoft.com/office/drawing/2014/main" id="{73B91576-6032-476F-99D6-46EBEE4B1451}"/>
+                <a16:creationId xmlns:a16="http://schemas.microsoft.com/office/drawing/2014/main" id="{98A696B9-906F-413E-B1F5-0AFD6FF1F1C3}"/>
               </a:ext>
             </a:extLst>
           </p:cNvPr>
@@ -3786,12 +3786,12 @@
   </p:cSld>
   <p:clrMap bg1="lt1" tx1="dk1" bg2="lt2" tx2="dk2" accent1="accent1" accent2="accent2" accent3="accent3" accent4="accent4" accent5="accent5" accent6="accent6" hlink="hlink" folHlink="folHlink"/>
   <p:sldLayoutIdLst>
-    <p:sldLayoutId xmlns:r="http://schemas.openxmlformats.org/officeDocument/2006/relationships" id="2147483649" r:id="Rb11e5d2d20e74421"/>
-    <p:sldLayoutId xmlns:r="http://schemas.openxmlformats.org/officeDocument/2006/relationships" id="2147483650" r:id="Rd809c98742d5463e"/>
-    <p:sldLayoutId xmlns:r="http://schemas.openxmlformats.org/officeDocument/2006/relationships" id="2147483651" r:id="R17e5ba2fcfad4414"/>
-    <p:sldLayoutId xmlns:r="http://schemas.openxmlformats.org/officeDocument/2006/relationships" id="2147483652" r:id="R560a9eef64f343bf"/>
-    <p:sldLayoutId xmlns:r="http://schemas.openxmlformats.org/officeDocument/2006/relationships" id="2147483653" r:id="R3106657f0b734f5a"/>
-    <p:sldLayoutId xmlns:r="http://schemas.openxmlformats.org/officeDocument/2006/relationships" id="2147483654" r:id="Rb40afd0b0ba04dc9"/>
+    <p:sldLayoutId xmlns:r="http://schemas.openxmlformats.org/officeDocument/2006/relationships" id="2147483649" r:id="R8506a6d124254ea4"/>
+    <p:sldLayoutId xmlns:r="http://schemas.openxmlformats.org/officeDocument/2006/relationships" id="2147483650" r:id="Rf202c59fa5914e52"/>
+    <p:sldLayoutId xmlns:r="http://schemas.openxmlformats.org/officeDocument/2006/relationships" id="2147483651" r:id="R7a0c77a70ead4d78"/>
+    <p:sldLayoutId xmlns:r="http://schemas.openxmlformats.org/officeDocument/2006/relationships" id="2147483652" r:id="R7527f13d8386452f"/>
+    <p:sldLayoutId xmlns:r="http://schemas.openxmlformats.org/officeDocument/2006/relationships" id="2147483653" r:id="Rb8d86b1843ce4361"/>
+    <p:sldLayoutId xmlns:r="http://schemas.openxmlformats.org/officeDocument/2006/relationships" id="2147483654" r:id="R686a7670ac384f91"/>
   </p:sldLayoutIdLst>
   <p:txStyles>
     <p:titleStyle>
@@ -4342,7 +4342,7 @@
           <p:cNvPr id="6" name="">
             <a:extLst xmlns:a="http://schemas.openxmlformats.org/drawingml/2006/main">
               <a:ext uri="{FF2B5EF4-FFF2-40B4-BE49-F238E27FC236}">
-                <a16:creationId xmlns:a16="http://schemas.microsoft.com/office/drawing/2014/main" id="{F56B6E85-53B6-445A-9796-F47A3F79536E}"/>
+                <a16:creationId xmlns:a16="http://schemas.microsoft.com/office/drawing/2014/main" id="{07E350EC-A0DF-43B8-B847-20B7326C5121}"/>
               </a:ext>
             </a:extLst>
           </p:cNvPr>
@@ -4498,7 +4498,7 @@
           <p:cNvPr id="2" name="">
             <a:extLst xmlns:a="http://schemas.openxmlformats.org/drawingml/2006/main">
               <a:ext uri="{FF2B5EF4-FFF2-40B4-BE49-F238E27FC236}">
-                <a16:creationId xmlns:a16="http://schemas.microsoft.com/office/drawing/2014/main" id="{3D827959-DBFF-4A1E-9322-76F9EBD78B76}"/>
+                <a16:creationId xmlns:a16="http://schemas.microsoft.com/office/drawing/2014/main" id="{FEB21426-3BAC-46E3-B8E0-90A6DB1C967B}"/>
               </a:ext>
             </a:extLst>
           </p:cNvPr>
@@ -4654,7 +4654,7 @@
           <p:cNvPr id="3" name="">
             <a:extLst xmlns:a="http://schemas.openxmlformats.org/drawingml/2006/main">
               <a:ext uri="{FF2B5EF4-FFF2-40B4-BE49-F238E27FC236}">
-                <a16:creationId xmlns:a16="http://schemas.microsoft.com/office/drawing/2014/main" id="{65F2D625-84B0-48D2-B89F-82B5B37BFFC7}"/>
+                <a16:creationId xmlns:a16="http://schemas.microsoft.com/office/drawing/2014/main" id="{60E0489F-4848-4664-B0A6-8B3F5388DD9D}"/>
               </a:ext>
             </a:extLst>
           </p:cNvPr>
@@ -4810,7 +4810,7 @@
           <p:cNvPr id="4" name="">
             <a:extLst xmlns:a="http://schemas.openxmlformats.org/drawingml/2006/main">
               <a:ext uri="{FF2B5EF4-FFF2-40B4-BE49-F238E27FC236}">
-                <a16:creationId xmlns:a16="http://schemas.microsoft.com/office/drawing/2014/main" id="{42E678BD-BE42-4B7C-88E4-C82F93D0E5C8}"/>
+                <a16:creationId xmlns:a16="http://schemas.microsoft.com/office/drawing/2014/main" id="{23900BE0-911F-48E2-8810-C960F590B59A}"/>
               </a:ext>
             </a:extLst>
           </p:cNvPr>
@@ -4966,7 +4966,7 @@
           <p:cNvPr id="5" name="">
             <a:extLst xmlns:a="http://schemas.openxmlformats.org/drawingml/2006/main">
               <a:ext uri="{FF2B5EF4-FFF2-40B4-BE49-F238E27FC236}">
-                <a16:creationId xmlns:a16="http://schemas.microsoft.com/office/drawing/2014/main" id="{7CC9CADB-B8BA-431E-B2F4-2B5BF0D6D294}"/>
+                <a16:creationId xmlns:a16="http://schemas.microsoft.com/office/drawing/2014/main" id="{DD8EC020-9180-4130-8C5B-A31F99498E13}"/>
               </a:ext>
             </a:extLst>
           </p:cNvPr>
@@ -5120,7 +5120,7 @@
     </p:spTree>
     <p:extLst>
       <p:ext uri="{BB962C8B-B14F-4D97-AF65-F5344CB8AC3E}">
-        <p14:creationId xmlns:p14="http://schemas.microsoft.com/office/powerpoint/2010/main" val="836325148"/>
+        <p14:creationId xmlns:p14="http://schemas.microsoft.com/office/powerpoint/2010/main" val="1078810008"/>
       </p:ext>
     </p:extLst>
   </p:cSld>
@@ -5151,7 +5151,7 @@
           <p:cNvPr id="8" name="">
             <a:extLst xmlns:a="http://schemas.openxmlformats.org/drawingml/2006/main">
               <a:ext uri="{FF2B5EF4-FFF2-40B4-BE49-F238E27FC236}">
-                <a16:creationId xmlns:a16="http://schemas.microsoft.com/office/drawing/2014/main" id="{59800900-1F7E-41BD-88DF-43CAFE961D90}"/>
+                <a16:creationId xmlns:a16="http://schemas.microsoft.com/office/drawing/2014/main" id="{EEBBF2CF-8EF3-4EE2-A3DF-597302BEEE86}"/>
               </a:ext>
             </a:extLst>
           </p:cNvPr>
@@ -5307,7 +5307,7 @@
           <p:cNvPr id="2" name="">
             <a:extLst xmlns:a="http://schemas.openxmlformats.org/drawingml/2006/main">
               <a:ext uri="{FF2B5EF4-FFF2-40B4-BE49-F238E27FC236}">
-                <a16:creationId xmlns:a16="http://schemas.microsoft.com/office/drawing/2014/main" id="{E9B2186F-A62E-42DD-BACA-01F4C90067B2}"/>
+                <a16:creationId xmlns:a16="http://schemas.microsoft.com/office/drawing/2014/main" id="{CF43208F-9FB1-4CB1-B6B7-65E43F3945E8}"/>
               </a:ext>
             </a:extLst>
           </p:cNvPr>
@@ -5463,7 +5463,7 @@
           <p:cNvPr id="3" name="">
             <a:extLst xmlns:a="http://schemas.openxmlformats.org/drawingml/2006/main">
               <a:ext uri="{FF2B5EF4-FFF2-40B4-BE49-F238E27FC236}">
-                <a16:creationId xmlns:a16="http://schemas.microsoft.com/office/drawing/2014/main" id="{A1FD0A07-5DCD-4BE0-A7BC-7605480ACE89}"/>
+                <a16:creationId xmlns:a16="http://schemas.microsoft.com/office/drawing/2014/main" id="{CDB4AAED-0525-48F5-95B7-DBA29866F86E}"/>
               </a:ext>
             </a:extLst>
           </p:cNvPr>
@@ -5619,7 +5619,7 @@
           <p:cNvPr id="4" name="">
             <a:extLst xmlns:a="http://schemas.openxmlformats.org/drawingml/2006/main">
               <a:ext uri="{FF2B5EF4-FFF2-40B4-BE49-F238E27FC236}">
-                <a16:creationId xmlns:a16="http://schemas.microsoft.com/office/drawing/2014/main" id="{6D9DE2E8-2CAF-4E09-9F9A-AEBAB2709788}"/>
+                <a16:creationId xmlns:a16="http://schemas.microsoft.com/office/drawing/2014/main" id="{136C9619-5802-44C8-AC4D-C15154F5752E}"/>
               </a:ext>
             </a:extLst>
           </p:cNvPr>
@@ -5775,7 +5775,7 @@
           <p:cNvPr id="5" name="">
             <a:extLst xmlns:a="http://schemas.openxmlformats.org/drawingml/2006/main">
               <a:ext uri="{FF2B5EF4-FFF2-40B4-BE49-F238E27FC236}">
-                <a16:creationId xmlns:a16="http://schemas.microsoft.com/office/drawing/2014/main" id="{BECA70AA-6302-4C63-9A3A-AF267B57DDD9}"/>
+                <a16:creationId xmlns:a16="http://schemas.microsoft.com/office/drawing/2014/main" id="{C485750E-6A04-4512-8BC1-FBE12243CDD7}"/>
               </a:ext>
             </a:extLst>
           </p:cNvPr>
@@ -5931,7 +5931,7 @@
           <p:cNvPr id="6" name="">
             <a:extLst xmlns:a="http://schemas.openxmlformats.org/drawingml/2006/main">
               <a:ext uri="{FF2B5EF4-FFF2-40B4-BE49-F238E27FC236}">
-                <a16:creationId xmlns:a16="http://schemas.microsoft.com/office/drawing/2014/main" id="{BE20E92E-75B4-4CC6-83BC-F35DE50707B2}"/>
+                <a16:creationId xmlns:a16="http://schemas.microsoft.com/office/drawing/2014/main" id="{532F0E86-679D-4658-9902-84B68B708AE5}"/>
               </a:ext>
             </a:extLst>
           </p:cNvPr>
@@ -6077,7 +6077,7 @@
                 <a:ea typeface="Segoe UI"/>
                 <a:cs typeface="Segoe UI"/>
               </a:rPr>
-              <a:t>Next: real APIs, database enforcement and AWS deployment</a:t>
+              <a:t>Next: local Next.js, full Supabase and server security</a:t>
             </a:r>
           </a:p>
         </p:txBody>
@@ -6087,7 +6087,7 @@
           <p:cNvPr id="7" name="">
             <a:extLst xmlns:a="http://schemas.openxmlformats.org/drawingml/2006/main">
               <a:ext uri="{FF2B5EF4-FFF2-40B4-BE49-F238E27FC236}">
-                <a16:creationId xmlns:a16="http://schemas.microsoft.com/office/drawing/2014/main" id="{6FFB1342-ABC8-41D8-A9B6-BCA6D8DD900B}"/>
+                <a16:creationId xmlns:a16="http://schemas.microsoft.com/office/drawing/2014/main" id="{B294CE44-C9D3-47B3-91ED-0B76B4892C02}"/>
               </a:ext>
             </a:extLst>
           </p:cNvPr>
@@ -6233,7 +6233,7 @@
                 <a:ea typeface="Segoe UI"/>
                 <a:cs typeface="Segoe UI"/>
               </a:rPr>
-              <a:t>Challenges: shared contracts, stack acceptance and AWS access</a:t>
+              <a:t>Open: lecturer acceptance and the Week 14 calendar date</a:t>
             </a:r>
           </a:p>
         </p:txBody>
@@ -6241,7 +6241,7 @@
     </p:spTree>
     <p:extLst>
       <p:ext uri="{BB962C8B-B14F-4D97-AF65-F5344CB8AC3E}">
-        <p14:creationId xmlns:p14="http://schemas.microsoft.com/office/powerpoint/2010/main" val="1710270190"/>
+        <p14:creationId xmlns:p14="http://schemas.microsoft.com/office/powerpoint/2010/main" val="1237557122"/>
       </p:ext>
     </p:extLst>
   </p:cSld>
@@ -6272,7 +6272,7 @@
           <p:cNvPr id="5" name="">
             <a:extLst xmlns:a="http://schemas.openxmlformats.org/drawingml/2006/main">
               <a:ext uri="{FF2B5EF4-FFF2-40B4-BE49-F238E27FC236}">
-                <a16:creationId xmlns:a16="http://schemas.microsoft.com/office/drawing/2014/main" id="{4457EAD4-B3B1-4C76-9A26-674407A9ECD9}"/>
+                <a16:creationId xmlns:a16="http://schemas.microsoft.com/office/drawing/2014/main" id="{2EB10F48-A402-4F07-911D-72C911CE688A}"/>
               </a:ext>
             </a:extLst>
           </p:cNvPr>
@@ -6428,7 +6428,7 @@
           <p:cNvPr id="2" name="">
             <a:extLst xmlns:a="http://schemas.openxmlformats.org/drawingml/2006/main">
               <a:ext uri="{FF2B5EF4-FFF2-40B4-BE49-F238E27FC236}">
-                <a16:creationId xmlns:a16="http://schemas.microsoft.com/office/drawing/2014/main" id="{181141BA-457F-41D1-8C6B-D038AED6B024}"/>
+                <a16:creationId xmlns:a16="http://schemas.microsoft.com/office/drawing/2014/main" id="{020AEAAB-A4C7-4F17-A543-AB584FA311CA}"/>
               </a:ext>
             </a:extLst>
           </p:cNvPr>
@@ -6584,7 +6584,7 @@
           <p:cNvPr id="3" name="">
             <a:extLst xmlns:a="http://schemas.openxmlformats.org/drawingml/2006/main">
               <a:ext uri="{FF2B5EF4-FFF2-40B4-BE49-F238E27FC236}">
-                <a16:creationId xmlns:a16="http://schemas.microsoft.com/office/drawing/2014/main" id="{C1B81A32-CED3-4B92-9E32-E54BD679715B}"/>
+                <a16:creationId xmlns:a16="http://schemas.microsoft.com/office/drawing/2014/main" id="{7AACE9EF-4F6C-498A-AF2B-22698EACC23B}"/>
               </a:ext>
             </a:extLst>
           </p:cNvPr>
@@ -6912,7 +6912,7 @@
                           <a:ea typeface="Segoe UI"/>
                           <a:cs typeface="Segoe UI"/>
                         </a:rPr>
-                        <a:t>PH3: full functionality and early AWS smoke</a:t>
+                        <a:t>PH3: full local functionality and production build</a:t>
                       </a:r>
                     </a:p>
                   </a:txBody>
@@ -6992,7 +6992,7 @@
                           <a:ea typeface="Segoe UI"/>
                           <a:cs typeface="Segoe UI"/>
                         </a:rPr>
-                        <a:t>PH4-PH5: security regression and AWS operations</a:t>
+                        <a:t>PH4-PH5: local security/recovery, then cloud</a:t>
                       </a:r>
                     </a:p>
                   </a:txBody>
@@ -7104,7 +7104,7 @@
           <p:cNvPr id="4" name="">
             <a:extLst xmlns:a="http://schemas.openxmlformats.org/drawingml/2006/main">
               <a:ext uri="{FF2B5EF4-FFF2-40B4-BE49-F238E27FC236}">
-                <a16:creationId xmlns:a16="http://schemas.microsoft.com/office/drawing/2014/main" id="{9969B535-F81F-4DD7-A92F-7456993B060A}"/>
+                <a16:creationId xmlns:a16="http://schemas.microsoft.com/office/drawing/2014/main" id="{450920A5-C2CF-4C5B-A7F1-C5E357316B29}"/>
               </a:ext>
             </a:extLst>
           </p:cNvPr>
@@ -7258,7 +7258,7 @@
     </p:spTree>
     <p:extLst>
       <p:ext uri="{BB962C8B-B14F-4D97-AF65-F5344CB8AC3E}">
-        <p14:creationId xmlns:p14="http://schemas.microsoft.com/office/powerpoint/2010/main" val="1587621731"/>
+        <p14:creationId xmlns:p14="http://schemas.microsoft.com/office/powerpoint/2010/main" val="1201289187"/>
       </p:ext>
     </p:extLst>
   </p:cSld>
@@ -7289,7 +7289,7 @@
           <p:cNvPr id="9" name="">
             <a:extLst xmlns:a="http://schemas.openxmlformats.org/drawingml/2006/main">
               <a:ext uri="{FF2B5EF4-FFF2-40B4-BE49-F238E27FC236}">
-                <a16:creationId xmlns:a16="http://schemas.microsoft.com/office/drawing/2014/main" id="{B77C9FA7-0844-438A-A82E-EFC36B924CBB}"/>
+                <a16:creationId xmlns:a16="http://schemas.microsoft.com/office/drawing/2014/main" id="{3AB79806-71C9-478C-A82F-649E9CFAF899}"/>
               </a:ext>
             </a:extLst>
           </p:cNvPr>
@@ -7445,7 +7445,7 @@
           <p:cNvPr id="2" name="">
             <a:extLst xmlns:a="http://schemas.openxmlformats.org/drawingml/2006/main">
               <a:ext uri="{FF2B5EF4-FFF2-40B4-BE49-F238E27FC236}">
-                <a16:creationId xmlns:a16="http://schemas.microsoft.com/office/drawing/2014/main" id="{55C26603-C70E-401D-8163-64F9AC4FE58F}"/>
+                <a16:creationId xmlns:a16="http://schemas.microsoft.com/office/drawing/2014/main" id="{3600479B-C7B9-46D1-9903-3B4255DDE0FC}"/>
               </a:ext>
             </a:extLst>
           </p:cNvPr>
@@ -7601,7 +7601,7 @@
           <p:cNvPr id="3" name="">
             <a:extLst xmlns:a="http://schemas.openxmlformats.org/drawingml/2006/main">
               <a:ext uri="{FF2B5EF4-FFF2-40B4-BE49-F238E27FC236}">
-                <a16:creationId xmlns:a16="http://schemas.microsoft.com/office/drawing/2014/main" id="{9D1CB245-30E8-415C-AE07-742772A0C889}"/>
+                <a16:creationId xmlns:a16="http://schemas.microsoft.com/office/drawing/2014/main" id="{B392A45A-B97D-4955-80B1-23F471E2D3C7}"/>
               </a:ext>
             </a:extLst>
           </p:cNvPr>
@@ -7757,7 +7757,7 @@
           <p:cNvPr id="4" name="">
             <a:extLst xmlns:a="http://schemas.openxmlformats.org/drawingml/2006/main">
               <a:ext uri="{FF2B5EF4-FFF2-40B4-BE49-F238E27FC236}">
-                <a16:creationId xmlns:a16="http://schemas.microsoft.com/office/drawing/2014/main" id="{F043C417-4A4C-4E06-BF8F-424FFBE4C21F}"/>
+                <a16:creationId xmlns:a16="http://schemas.microsoft.com/office/drawing/2014/main" id="{447D13C6-B315-4AD5-A3BE-EF2A06616FA5}"/>
               </a:ext>
             </a:extLst>
           </p:cNvPr>
@@ -7913,7 +7913,7 @@
           <p:cNvPr id="5" name="">
             <a:extLst xmlns:a="http://schemas.openxmlformats.org/drawingml/2006/main">
               <a:ext uri="{FF2B5EF4-FFF2-40B4-BE49-F238E27FC236}">
-                <a16:creationId xmlns:a16="http://schemas.microsoft.com/office/drawing/2014/main" id="{D7712879-2DDA-464D-86E6-B249FA4D1785}"/>
+                <a16:creationId xmlns:a16="http://schemas.microsoft.com/office/drawing/2014/main" id="{B0417B66-E3DE-4C82-9F36-7DA851E13263}"/>
               </a:ext>
             </a:extLst>
           </p:cNvPr>
@@ -8069,7 +8069,7 @@
           <p:cNvPr id="6" name="">
             <a:extLst xmlns:a="http://schemas.openxmlformats.org/drawingml/2006/main">
               <a:ext uri="{FF2B5EF4-FFF2-40B4-BE49-F238E27FC236}">
-                <a16:creationId xmlns:a16="http://schemas.microsoft.com/office/drawing/2014/main" id="{02E8C933-0253-45AE-8162-E88B19F3B8CD}"/>
+                <a16:creationId xmlns:a16="http://schemas.microsoft.com/office/drawing/2014/main" id="{F298135F-603A-4764-8F54-19AD902FA49D}"/>
               </a:ext>
             </a:extLst>
           </p:cNvPr>
@@ -8225,7 +8225,7 @@
           <p:cNvPr id="7" name="">
             <a:extLst xmlns:a="http://schemas.openxmlformats.org/drawingml/2006/main">
               <a:ext uri="{FF2B5EF4-FFF2-40B4-BE49-F238E27FC236}">
-                <a16:creationId xmlns:a16="http://schemas.microsoft.com/office/drawing/2014/main" id="{C027CCF6-1FDC-45AD-8BB1-4688FB77C3B5}"/>
+                <a16:creationId xmlns:a16="http://schemas.microsoft.com/office/drawing/2014/main" id="{070FF08A-23D1-46C0-B809-28B689B53366}"/>
               </a:ext>
             </a:extLst>
           </p:cNvPr>
@@ -8381,7 +8381,7 @@
           <p:cNvPr id="8" name="">
             <a:extLst xmlns:a="http://schemas.openxmlformats.org/drawingml/2006/main">
               <a:ext uri="{FF2B5EF4-FFF2-40B4-BE49-F238E27FC236}">
-                <a16:creationId xmlns:a16="http://schemas.microsoft.com/office/drawing/2014/main" id="{3E0E61B3-8126-44D0-84DE-A0B23B870176}"/>
+                <a16:creationId xmlns:a16="http://schemas.microsoft.com/office/drawing/2014/main" id="{0D1886E7-9AC0-494A-864F-72815515B8BE}"/>
               </a:ext>
             </a:extLst>
           </p:cNvPr>
@@ -8535,7 +8535,7 @@
     </p:spTree>
     <p:extLst>
       <p:ext uri="{BB962C8B-B14F-4D97-AF65-F5344CB8AC3E}">
-        <p14:creationId xmlns:p14="http://schemas.microsoft.com/office/powerpoint/2010/main" val="2082546573"/>
+        <p14:creationId xmlns:p14="http://schemas.microsoft.com/office/powerpoint/2010/main" val="877558643"/>
       </p:ext>
     </p:extLst>
   </p:cSld>
@@ -8566,7 +8566,7 @@
           <p:cNvPr id="5" name="">
             <a:extLst xmlns:a="http://schemas.openxmlformats.org/drawingml/2006/main">
               <a:ext uri="{FF2B5EF4-FFF2-40B4-BE49-F238E27FC236}">
-                <a16:creationId xmlns:a16="http://schemas.microsoft.com/office/drawing/2014/main" id="{EDC54C96-1CAF-42D1-9E9A-CEA0108F562C}"/>
+                <a16:creationId xmlns:a16="http://schemas.microsoft.com/office/drawing/2014/main" id="{94BA8E62-3226-4E18-ACD9-7448C428AE54}"/>
               </a:ext>
             </a:extLst>
           </p:cNvPr>
@@ -8722,7 +8722,7 @@
           <p:cNvPr id="2" name="">
             <a:extLst xmlns:a="http://schemas.openxmlformats.org/drawingml/2006/main">
               <a:ext uri="{FF2B5EF4-FFF2-40B4-BE49-F238E27FC236}">
-                <a16:creationId xmlns:a16="http://schemas.microsoft.com/office/drawing/2014/main" id="{A5FBEB02-CF6E-4B92-8EAE-7EFF974117EF}"/>
+                <a16:creationId xmlns:a16="http://schemas.microsoft.com/office/drawing/2014/main" id="{C690568F-1F40-44E4-9B23-419A0E36CCD1}"/>
               </a:ext>
             </a:extLst>
           </p:cNvPr>
@@ -8878,7 +8878,7 @@
           <p:cNvPr id="3" name="">
             <a:extLst xmlns:a="http://schemas.openxmlformats.org/drawingml/2006/main">
               <a:ext uri="{FF2B5EF4-FFF2-40B4-BE49-F238E27FC236}">
-                <a16:creationId xmlns:a16="http://schemas.microsoft.com/office/drawing/2014/main" id="{0E1BE273-1A5B-4559-A8A9-E80708D484D9}"/>
+                <a16:creationId xmlns:a16="http://schemas.microsoft.com/office/drawing/2014/main" id="{796F3D3B-87A3-466B-A9FC-57A4704255EC}"/>
               </a:ext>
             </a:extLst>
           </p:cNvPr>
@@ -9389,7 +9389,7 @@
           <p:cNvPr id="4" name="">
             <a:extLst xmlns:a="http://schemas.openxmlformats.org/drawingml/2006/main">
               <a:ext uri="{FF2B5EF4-FFF2-40B4-BE49-F238E27FC236}">
-                <a16:creationId xmlns:a16="http://schemas.microsoft.com/office/drawing/2014/main" id="{41AE4F8B-ED4E-45FE-B7B7-676042A75045}"/>
+                <a16:creationId xmlns:a16="http://schemas.microsoft.com/office/drawing/2014/main" id="{8701A8AA-F0B9-4C95-AABA-B505ED4E1246}"/>
               </a:ext>
             </a:extLst>
           </p:cNvPr>
@@ -9543,7 +9543,7 @@
     </p:spTree>
     <p:extLst>
       <p:ext uri="{BB962C8B-B14F-4D97-AF65-F5344CB8AC3E}">
-        <p14:creationId xmlns:p14="http://schemas.microsoft.com/office/powerpoint/2010/main" val="1754225218"/>
+        <p14:creationId xmlns:p14="http://schemas.microsoft.com/office/powerpoint/2010/main" val="1673258040"/>
       </p:ext>
     </p:extLst>
   </p:cSld>
@@ -9574,7 +9574,7 @@
           <p:cNvPr id="13" name="">
             <a:extLst xmlns:a="http://schemas.openxmlformats.org/drawingml/2006/main">
               <a:ext uri="{FF2B5EF4-FFF2-40B4-BE49-F238E27FC236}">
-                <a16:creationId xmlns:a16="http://schemas.microsoft.com/office/drawing/2014/main" id="{132D8313-13B2-4BC5-B893-5AB820793846}"/>
+                <a16:creationId xmlns:a16="http://schemas.microsoft.com/office/drawing/2014/main" id="{8958F44D-3921-48FD-89B3-FB183F578D25}"/>
               </a:ext>
             </a:extLst>
           </p:cNvPr>
@@ -9604,7 +9604,7 @@
           <p:cNvPr id="12" name="">
             <a:extLst xmlns:a="http://schemas.openxmlformats.org/drawingml/2006/main">
               <a:ext uri="{FF2B5EF4-FFF2-40B4-BE49-F238E27FC236}">
-                <a16:creationId xmlns:a16="http://schemas.microsoft.com/office/drawing/2014/main" id="{DAFE9EF5-121F-4440-BFCE-854DD8EB8DE7}"/>
+                <a16:creationId xmlns:a16="http://schemas.microsoft.com/office/drawing/2014/main" id="{93FFF30B-4948-4801-BF54-4FE3D04D891D}"/>
               </a:ext>
             </a:extLst>
           </p:cNvPr>
@@ -9634,7 +9634,7 @@
           <p:cNvPr id="17" name="">
             <a:extLst xmlns:a="http://schemas.openxmlformats.org/drawingml/2006/main">
               <a:ext uri="{FF2B5EF4-FFF2-40B4-BE49-F238E27FC236}">
-                <a16:creationId xmlns:a16="http://schemas.microsoft.com/office/drawing/2014/main" id="{EC7751B6-F8EC-4D4F-AE48-1C06D30DFF54}"/>
+                <a16:creationId xmlns:a16="http://schemas.microsoft.com/office/drawing/2014/main" id="{3E342F07-02E6-4975-8DD4-E43AF51EE3F7}"/>
               </a:ext>
             </a:extLst>
           </p:cNvPr>
@@ -9790,7 +9790,7 @@
           <p:cNvPr id="2" name="">
             <a:extLst xmlns:a="http://schemas.openxmlformats.org/drawingml/2006/main">
               <a:ext uri="{FF2B5EF4-FFF2-40B4-BE49-F238E27FC236}">
-                <a16:creationId xmlns:a16="http://schemas.microsoft.com/office/drawing/2014/main" id="{B6537011-5C50-42D7-8652-F66E3840B137}"/>
+                <a16:creationId xmlns:a16="http://schemas.microsoft.com/office/drawing/2014/main" id="{65FE1F50-DB15-49DB-87E6-C7BF7E36AE0B}"/>
               </a:ext>
             </a:extLst>
           </p:cNvPr>
@@ -9946,7 +9946,7 @@
           <p:cNvPr id="3" name="">
             <a:extLst xmlns:a="http://schemas.openxmlformats.org/drawingml/2006/main">
               <a:ext uri="{FF2B5EF4-FFF2-40B4-BE49-F238E27FC236}">
-                <a16:creationId xmlns:a16="http://schemas.microsoft.com/office/drawing/2014/main" id="{332B7B86-DF62-4B94-942B-DE1EB1C558A4}"/>
+                <a16:creationId xmlns:a16="http://schemas.microsoft.com/office/drawing/2014/main" id="{1A171967-50DE-4C6C-974F-08F730E12D32}"/>
               </a:ext>
             </a:extLst>
           </p:cNvPr>
@@ -9978,7 +9978,7 @@
           <p:cNvPr id="4" name="">
             <a:extLst xmlns:a="http://schemas.openxmlformats.org/drawingml/2006/main">
               <a:ext uri="{FF2B5EF4-FFF2-40B4-BE49-F238E27FC236}">
-                <a16:creationId xmlns:a16="http://schemas.microsoft.com/office/drawing/2014/main" id="{E0325E5D-9743-4186-AD87-5E09A9A27147}"/>
+                <a16:creationId xmlns:a16="http://schemas.microsoft.com/office/drawing/2014/main" id="{87678D2B-634C-480A-AFBA-911AE9B6F408}"/>
               </a:ext>
             </a:extLst>
           </p:cNvPr>
@@ -10124,7 +10124,7 @@
                 <a:ea typeface="Segoe UI"/>
                 <a:cs typeface="Segoe UI"/>
               </a:rPr>
-              <a:t>React + TypeScript</a:t>
+              <a:t>Next.js pages</a:t>
             </a:r>
           </a:p>
         </p:txBody>
@@ -10134,7 +10134,7 @@
           <p:cNvPr id="5" name="">
             <a:extLst xmlns:a="http://schemas.openxmlformats.org/drawingml/2006/main">
               <a:ext uri="{FF2B5EF4-FFF2-40B4-BE49-F238E27FC236}">
-                <a16:creationId xmlns:a16="http://schemas.microsoft.com/office/drawing/2014/main" id="{63A6D946-961A-4B88-8CAF-413F075D7CD6}"/>
+                <a16:creationId xmlns:a16="http://schemas.microsoft.com/office/drawing/2014/main" id="{64F328F2-A490-4EC7-80A1-8D1396CDC617}"/>
               </a:ext>
             </a:extLst>
           </p:cNvPr>
@@ -10313,7 +10313,7 @@
           <p:cNvPr id="6" name="">
             <a:extLst xmlns:a="http://schemas.openxmlformats.org/drawingml/2006/main">
               <a:ext uri="{FF2B5EF4-FFF2-40B4-BE49-F238E27FC236}">
-                <a16:creationId xmlns:a16="http://schemas.microsoft.com/office/drawing/2014/main" id="{8306F704-7634-4550-86D5-D04A15A0EEBF}"/>
+                <a16:creationId xmlns:a16="http://schemas.microsoft.com/office/drawing/2014/main" id="{85F7CFB0-6361-493A-9D82-F799A2D6F90A}"/>
               </a:ext>
             </a:extLst>
           </p:cNvPr>
@@ -10345,7 +10345,7 @@
           <p:cNvPr id="7" name="">
             <a:extLst xmlns:a="http://schemas.openxmlformats.org/drawingml/2006/main">
               <a:ext uri="{FF2B5EF4-FFF2-40B4-BE49-F238E27FC236}">
-                <a16:creationId xmlns:a16="http://schemas.microsoft.com/office/drawing/2014/main" id="{867D71ED-1688-4D57-96EF-E0FD6B9928EF}"/>
+                <a16:creationId xmlns:a16="http://schemas.microsoft.com/office/drawing/2014/main" id="{54CA73E0-A351-4BAB-B09C-0FC915952E7B}"/>
               </a:ext>
             </a:extLst>
           </p:cNvPr>
@@ -10491,7 +10491,7 @@
                 <a:ea typeface="Segoe UI"/>
                 <a:cs typeface="Segoe UI"/>
               </a:rPr>
-              <a:t>FastAPI</a:t>
+              <a:t>Next.js server</a:t>
             </a:r>
           </a:p>
         </p:txBody>
@@ -10501,7 +10501,7 @@
           <p:cNvPr id="8" name="">
             <a:extLst xmlns:a="http://schemas.openxmlformats.org/drawingml/2006/main">
               <a:ext uri="{FF2B5EF4-FFF2-40B4-BE49-F238E27FC236}">
-                <a16:creationId xmlns:a16="http://schemas.microsoft.com/office/drawing/2014/main" id="{5D4C966A-22C7-437E-9C0F-201BE8599CC1}"/>
+                <a16:creationId xmlns:a16="http://schemas.microsoft.com/office/drawing/2014/main" id="{AEB7D4EF-DF24-4249-9A45-8A8CA3F57119}"/>
               </a:ext>
             </a:extLst>
           </p:cNvPr>
@@ -10647,7 +10647,7 @@
                 <a:ea typeface="Segoe UI"/>
                 <a:cs typeface="Segoe UI"/>
               </a:rPr>
-              <a:t>Shared authenticated APIs</a:t>
+              <a:t>Shared TypeScript services</a:t>
             </a:r>
           </a:p>
           <a:p xmlns:a="http://schemas.openxmlformats.org/drawingml/2006/main">
@@ -10670,7 +10670,7 @@
                 <a:ea typeface="Segoe UI"/>
                 <a:cs typeface="Segoe UI"/>
               </a:rPr>
-              <a:t>SQLAlchemy + Alembic</a:t>
+              <a:t>Zod + pg + SQL migrations</a:t>
             </a:r>
           </a:p>
         </p:txBody>
@@ -10680,7 +10680,7 @@
           <p:cNvPr id="9" name="">
             <a:extLst xmlns:a="http://schemas.openxmlformats.org/drawingml/2006/main">
               <a:ext uri="{FF2B5EF4-FFF2-40B4-BE49-F238E27FC236}">
-                <a16:creationId xmlns:a16="http://schemas.microsoft.com/office/drawing/2014/main" id="{2932F70F-05D4-4652-AE7E-1307FADA1721}"/>
+                <a16:creationId xmlns:a16="http://schemas.microsoft.com/office/drawing/2014/main" id="{260A9688-CC9E-47C9-8290-E72BFE5A37D4}"/>
               </a:ext>
             </a:extLst>
           </p:cNvPr>
@@ -10712,7 +10712,7 @@
           <p:cNvPr id="10" name="">
             <a:extLst xmlns:a="http://schemas.openxmlformats.org/drawingml/2006/main">
               <a:ext uri="{FF2B5EF4-FFF2-40B4-BE49-F238E27FC236}">
-                <a16:creationId xmlns:a16="http://schemas.microsoft.com/office/drawing/2014/main" id="{DD34A1D0-11AB-4E03-9BEA-D7F968882ED4}"/>
+                <a16:creationId xmlns:a16="http://schemas.microsoft.com/office/drawing/2014/main" id="{1BA334D9-7870-4536-9B69-B45B86A9030A}"/>
               </a:ext>
             </a:extLst>
           </p:cNvPr>
@@ -10858,7 +10858,7 @@
                 <a:ea typeface="Segoe UI"/>
                 <a:cs typeface="Segoe UI"/>
               </a:rPr>
-              <a:t>PostgreSQL</a:t>
+              <a:t>Supabase Docker</a:t>
             </a:r>
           </a:p>
         </p:txBody>
@@ -10868,7 +10868,7 @@
           <p:cNvPr id="11" name="">
             <a:extLst xmlns:a="http://schemas.openxmlformats.org/drawingml/2006/main">
               <a:ext uri="{FF2B5EF4-FFF2-40B4-BE49-F238E27FC236}">
-                <a16:creationId xmlns:a16="http://schemas.microsoft.com/office/drawing/2014/main" id="{54C565A5-9F43-49D7-ABA3-82C2147DC1B9}"/>
+                <a16:creationId xmlns:a16="http://schemas.microsoft.com/office/drawing/2014/main" id="{67F148B2-0F4F-4F3C-A299-E0264F0338C3}"/>
               </a:ext>
             </a:extLst>
           </p:cNvPr>
@@ -11014,7 +11014,7 @@
                 <a:ea typeface="Segoe UI"/>
                 <a:cs typeface="Segoe UI"/>
               </a:rPr>
-              <a:t>Private database</a:t>
+              <a:t>PostgreSQL + private Storage</a:t>
             </a:r>
           </a:p>
           <a:p xmlns:a="http://schemas.openxmlformats.org/drawingml/2006/main">
@@ -11037,7 +11037,7 @@
                 <a:ea typeface="Segoe UI"/>
                 <a:cs typeface="Segoe UI"/>
               </a:rPr>
-              <a:t>Row level security</a:t>
+              <a:t>Full local service stack</a:t>
             </a:r>
           </a:p>
         </p:txBody>
@@ -11047,7 +11047,7 @@
           <p:cNvPr id="14" name="">
             <a:extLst xmlns:a="http://schemas.openxmlformats.org/drawingml/2006/main">
               <a:ext uri="{FF2B5EF4-FFF2-40B4-BE49-F238E27FC236}">
-                <a16:creationId xmlns:a16="http://schemas.microsoft.com/office/drawing/2014/main" id="{6E57652D-BEDB-461C-9D55-2195E26C4F79}"/>
+                <a16:creationId xmlns:a16="http://schemas.microsoft.com/office/drawing/2014/main" id="{B68EB360-DE9B-4D81-90B7-B466EF8F06B6}"/>
               </a:ext>
             </a:extLst>
           </p:cNvPr>
@@ -11193,7 +11193,7 @@
                 <a:ea typeface="Segoe UI"/>
                 <a:cs typeface="Segoe UI"/>
               </a:rPr>
-              <a:t>Planned deployment: Docker Compose on AWS EC2 with HTTPS</a:t>
+              <a:t>Local first: one Next.js app and full Supabase Docker</a:t>
             </a:r>
           </a:p>
         </p:txBody>
@@ -11203,7 +11203,7 @@
           <p:cNvPr id="15" name="">
             <a:extLst xmlns:a="http://schemas.openxmlformats.org/drawingml/2006/main">
               <a:ext uri="{FF2B5EF4-FFF2-40B4-BE49-F238E27FC236}">
-                <a16:creationId xmlns:a16="http://schemas.microsoft.com/office/drawing/2014/main" id="{5FAA9F88-A634-4CDC-8277-B977A3DEB0A6}"/>
+                <a16:creationId xmlns:a16="http://schemas.microsoft.com/office/drawing/2014/main" id="{C118EEC0-95A4-4FC8-96CA-9833F8E7BAA8}"/>
               </a:ext>
             </a:extLst>
           </p:cNvPr>
@@ -11359,7 +11359,7 @@
           <p:cNvPr id="16" name="">
             <a:extLst xmlns:a="http://schemas.openxmlformats.org/drawingml/2006/main">
               <a:ext uri="{FF2B5EF4-FFF2-40B4-BE49-F238E27FC236}">
-                <a16:creationId xmlns:a16="http://schemas.microsoft.com/office/drawing/2014/main" id="{BD4E4A50-BC17-46E2-8AD7-167CA722207B}"/>
+                <a16:creationId xmlns:a16="http://schemas.microsoft.com/office/drawing/2014/main" id="{98A7212E-E0F7-4B97-81A7-2D5439D764D5}"/>
               </a:ext>
             </a:extLst>
           </p:cNvPr>
@@ -11505,7 +11505,7 @@
                 <a:ea typeface="Segoe UI"/>
                 <a:cs typeface="Segoe UI"/>
               </a:rPr>
-              <a:t>FastAPI/PostgreSQL variation: lecturer acceptance unverified</a:t>
+              <a:t>Next.js/PostgreSQL: lecturer acceptance unverified</a:t>
             </a:r>
           </a:p>
         </p:txBody>
@@ -11513,7 +11513,7 @@
     </p:spTree>
     <p:extLst>
       <p:ext uri="{BB962C8B-B14F-4D97-AF65-F5344CB8AC3E}">
-        <p14:creationId xmlns:p14="http://schemas.microsoft.com/office/powerpoint/2010/main" val="1878057068"/>
+        <p14:creationId xmlns:p14="http://schemas.microsoft.com/office/powerpoint/2010/main" val="2026268085"/>
       </p:ext>
     </p:extLst>
   </p:cSld>
@@ -11544,7 +11544,7 @@
           <p:cNvPr id="22" name="">
             <a:extLst xmlns:a="http://schemas.openxmlformats.org/drawingml/2006/main">
               <a:ext uri="{FF2B5EF4-FFF2-40B4-BE49-F238E27FC236}">
-                <a16:creationId xmlns:a16="http://schemas.microsoft.com/office/drawing/2014/main" id="{3C96E150-3DCB-44EF-8744-30D3F0C0027E}"/>
+                <a16:creationId xmlns:a16="http://schemas.microsoft.com/office/drawing/2014/main" id="{32ECB3C1-0D33-4DBD-8818-2AEB8EFC6885}"/>
               </a:ext>
             </a:extLst>
           </p:cNvPr>
@@ -11577,7 +11577,7 @@
           <p:cNvPr id="21" name="">
             <a:extLst xmlns:a="http://schemas.openxmlformats.org/drawingml/2006/main">
               <a:ext uri="{FF2B5EF4-FFF2-40B4-BE49-F238E27FC236}">
-                <a16:creationId xmlns:a16="http://schemas.microsoft.com/office/drawing/2014/main" id="{36D18214-5C2E-41C2-B9A7-55D5F1A1800E}"/>
+                <a16:creationId xmlns:a16="http://schemas.microsoft.com/office/drawing/2014/main" id="{6ADCAC90-CE0A-4D28-8631-403E4FBD21CF}"/>
               </a:ext>
             </a:extLst>
           </p:cNvPr>
@@ -11610,7 +11610,7 @@
           <p:cNvPr id="20" name="">
             <a:extLst xmlns:a="http://schemas.openxmlformats.org/drawingml/2006/main">
               <a:ext uri="{FF2B5EF4-FFF2-40B4-BE49-F238E27FC236}">
-                <a16:creationId xmlns:a16="http://schemas.microsoft.com/office/drawing/2014/main" id="{1AA68732-3A0E-45BA-99DE-DDC1C14099E4}"/>
+                <a16:creationId xmlns:a16="http://schemas.microsoft.com/office/drawing/2014/main" id="{3B7A7656-9BBB-4990-BDDC-85547ED1689A}"/>
               </a:ext>
             </a:extLst>
           </p:cNvPr>
@@ -11642,7 +11642,7 @@
           <p:cNvPr id="19" name="">
             <a:extLst xmlns:a="http://schemas.openxmlformats.org/drawingml/2006/main">
               <a:ext uri="{FF2B5EF4-FFF2-40B4-BE49-F238E27FC236}">
-                <a16:creationId xmlns:a16="http://schemas.microsoft.com/office/drawing/2014/main" id="{FB698505-01D4-4B82-B04E-895C64D68006}"/>
+                <a16:creationId xmlns:a16="http://schemas.microsoft.com/office/drawing/2014/main" id="{13ABF4E9-D806-4C8B-A528-C22B17C6A9BE}"/>
               </a:ext>
             </a:extLst>
           </p:cNvPr>
@@ -11674,7 +11674,7 @@
           <p:cNvPr id="18" name="">
             <a:extLst xmlns:a="http://schemas.openxmlformats.org/drawingml/2006/main">
               <a:ext uri="{FF2B5EF4-FFF2-40B4-BE49-F238E27FC236}">
-                <a16:creationId xmlns:a16="http://schemas.microsoft.com/office/drawing/2014/main" id="{C8F0F1D0-CB49-4008-9D79-DFC93583BFCF}"/>
+                <a16:creationId xmlns:a16="http://schemas.microsoft.com/office/drawing/2014/main" id="{22D7CB5D-6A76-413E-898B-8E583A78B206}"/>
               </a:ext>
             </a:extLst>
           </p:cNvPr>
@@ -11706,7 +11706,7 @@
           <p:cNvPr id="27" name="">
             <a:extLst xmlns:a="http://schemas.openxmlformats.org/drawingml/2006/main">
               <a:ext uri="{FF2B5EF4-FFF2-40B4-BE49-F238E27FC236}">
-                <a16:creationId xmlns:a16="http://schemas.microsoft.com/office/drawing/2014/main" id="{854D5367-E018-4750-A21A-591988F7BF02}"/>
+                <a16:creationId xmlns:a16="http://schemas.microsoft.com/office/drawing/2014/main" id="{1D5442A1-A789-4719-A2B5-5BEC3907E6C8}"/>
               </a:ext>
             </a:extLst>
           </p:cNvPr>
@@ -11862,7 +11862,7 @@
           <p:cNvPr id="2" name="">
             <a:extLst xmlns:a="http://schemas.openxmlformats.org/drawingml/2006/main">
               <a:ext uri="{FF2B5EF4-FFF2-40B4-BE49-F238E27FC236}">
-                <a16:creationId xmlns:a16="http://schemas.microsoft.com/office/drawing/2014/main" id="{5E154786-C786-4D36-8595-26BF37F39967}"/>
+                <a16:creationId xmlns:a16="http://schemas.microsoft.com/office/drawing/2014/main" id="{78AF3A52-9043-4648-8FDB-344B2E2D949C}"/>
               </a:ext>
             </a:extLst>
           </p:cNvPr>
@@ -12018,7 +12018,7 @@
           <p:cNvPr id="3" name="">
             <a:extLst xmlns:a="http://schemas.openxmlformats.org/drawingml/2006/main">
               <a:ext uri="{FF2B5EF4-FFF2-40B4-BE49-F238E27FC236}">
-                <a16:creationId xmlns:a16="http://schemas.microsoft.com/office/drawing/2014/main" id="{3DCEE871-C449-44A4-8233-1C68D1DE5B9B}"/>
+                <a16:creationId xmlns:a16="http://schemas.microsoft.com/office/drawing/2014/main" id="{141222C7-A386-4583-81B9-933679B4E58B}"/>
               </a:ext>
             </a:extLst>
           </p:cNvPr>
@@ -12050,7 +12050,7 @@
           <p:cNvPr id="4" name="">
             <a:extLst xmlns:a="http://schemas.openxmlformats.org/drawingml/2006/main">
               <a:ext uri="{FF2B5EF4-FFF2-40B4-BE49-F238E27FC236}">
-                <a16:creationId xmlns:a16="http://schemas.microsoft.com/office/drawing/2014/main" id="{4C267B27-8CB3-40E8-8623-525E01AFF4BD}"/>
+                <a16:creationId xmlns:a16="http://schemas.microsoft.com/office/drawing/2014/main" id="{1BD7E784-94A8-4392-9200-4030A070FE69}"/>
               </a:ext>
             </a:extLst>
           </p:cNvPr>
@@ -12206,7 +12206,7 @@
           <p:cNvPr id="5" name="">
             <a:extLst xmlns:a="http://schemas.openxmlformats.org/drawingml/2006/main">
               <a:ext uri="{FF2B5EF4-FFF2-40B4-BE49-F238E27FC236}">
-                <a16:creationId xmlns:a16="http://schemas.microsoft.com/office/drawing/2014/main" id="{B606EAF8-DB2B-4514-9F56-DB75C6AD535E}"/>
+                <a16:creationId xmlns:a16="http://schemas.microsoft.com/office/drawing/2014/main" id="{12BA1105-0C7E-4040-B6D3-C0DE65CE89E1}"/>
               </a:ext>
             </a:extLst>
           </p:cNvPr>
@@ -12408,7 +12408,7 @@
           <p:cNvPr id="6" name="">
             <a:extLst xmlns:a="http://schemas.openxmlformats.org/drawingml/2006/main">
               <a:ext uri="{FF2B5EF4-FFF2-40B4-BE49-F238E27FC236}">
-                <a16:creationId xmlns:a16="http://schemas.microsoft.com/office/drawing/2014/main" id="{530F6E5A-29F3-4114-BFBC-4FFEB43F055D}"/>
+                <a16:creationId xmlns:a16="http://schemas.microsoft.com/office/drawing/2014/main" id="{49952A28-12B9-44FB-BBEE-4AEEAD24BBE4}"/>
               </a:ext>
             </a:extLst>
           </p:cNvPr>
@@ -12440,7 +12440,7 @@
           <p:cNvPr id="7" name="">
             <a:extLst xmlns:a="http://schemas.openxmlformats.org/drawingml/2006/main">
               <a:ext uri="{FF2B5EF4-FFF2-40B4-BE49-F238E27FC236}">
-                <a16:creationId xmlns:a16="http://schemas.microsoft.com/office/drawing/2014/main" id="{06730FC9-29E4-4766-A391-AA0FD9052B6F}"/>
+                <a16:creationId xmlns:a16="http://schemas.microsoft.com/office/drawing/2014/main" id="{A8F1F32E-B1D6-43E9-9D17-A5A74A8A378D}"/>
               </a:ext>
             </a:extLst>
           </p:cNvPr>
@@ -12596,7 +12596,7 @@
           <p:cNvPr id="8" name="">
             <a:extLst xmlns:a="http://schemas.openxmlformats.org/drawingml/2006/main">
               <a:ext uri="{FF2B5EF4-FFF2-40B4-BE49-F238E27FC236}">
-                <a16:creationId xmlns:a16="http://schemas.microsoft.com/office/drawing/2014/main" id="{76B7070D-0029-434B-ADA5-38CC4A264F2B}"/>
+                <a16:creationId xmlns:a16="http://schemas.microsoft.com/office/drawing/2014/main" id="{8783DDF9-6958-4805-9F87-C6C6155CD6BB}"/>
               </a:ext>
             </a:extLst>
           </p:cNvPr>
@@ -12821,7 +12821,7 @@
           <p:cNvPr id="9" name="">
             <a:extLst xmlns:a="http://schemas.openxmlformats.org/drawingml/2006/main">
               <a:ext uri="{FF2B5EF4-FFF2-40B4-BE49-F238E27FC236}">
-                <a16:creationId xmlns:a16="http://schemas.microsoft.com/office/drawing/2014/main" id="{60566968-F8F9-47FF-A3F4-7C520046B7C9}"/>
+                <a16:creationId xmlns:a16="http://schemas.microsoft.com/office/drawing/2014/main" id="{9F26977B-4ED6-458D-A0F7-00E97EF62EC4}"/>
               </a:ext>
             </a:extLst>
           </p:cNvPr>
@@ -12853,7 +12853,7 @@
           <p:cNvPr id="10" name="">
             <a:extLst xmlns:a="http://schemas.openxmlformats.org/drawingml/2006/main">
               <a:ext uri="{FF2B5EF4-FFF2-40B4-BE49-F238E27FC236}">
-                <a16:creationId xmlns:a16="http://schemas.microsoft.com/office/drawing/2014/main" id="{8F35B857-374F-47F8-BB8B-434D8506E10F}"/>
+                <a16:creationId xmlns:a16="http://schemas.microsoft.com/office/drawing/2014/main" id="{7DA9C90B-C623-461F-AE5A-E0DF56063492}"/>
               </a:ext>
             </a:extLst>
           </p:cNvPr>
@@ -13009,7 +13009,7 @@
           <p:cNvPr id="11" name="">
             <a:extLst xmlns:a="http://schemas.openxmlformats.org/drawingml/2006/main">
               <a:ext uri="{FF2B5EF4-FFF2-40B4-BE49-F238E27FC236}">
-                <a16:creationId xmlns:a16="http://schemas.microsoft.com/office/drawing/2014/main" id="{19A45CEC-3FF7-46D6-85DC-9787E864CD6F}"/>
+                <a16:creationId xmlns:a16="http://schemas.microsoft.com/office/drawing/2014/main" id="{C1E29D27-5188-4C5C-8366-981D804BFDA6}"/>
               </a:ext>
             </a:extLst>
           </p:cNvPr>
@@ -13188,7 +13188,7 @@
           <p:cNvPr id="12" name="">
             <a:extLst xmlns:a="http://schemas.openxmlformats.org/drawingml/2006/main">
               <a:ext uri="{FF2B5EF4-FFF2-40B4-BE49-F238E27FC236}">
-                <a16:creationId xmlns:a16="http://schemas.microsoft.com/office/drawing/2014/main" id="{53FF4AD9-7A4B-492D-9750-323D9FD78D32}"/>
+                <a16:creationId xmlns:a16="http://schemas.microsoft.com/office/drawing/2014/main" id="{4102AFE3-E5CE-40F2-8B47-BC07EB070C42}"/>
               </a:ext>
             </a:extLst>
           </p:cNvPr>
@@ -13220,7 +13220,7 @@
           <p:cNvPr id="13" name="">
             <a:extLst xmlns:a="http://schemas.openxmlformats.org/drawingml/2006/main">
               <a:ext uri="{FF2B5EF4-FFF2-40B4-BE49-F238E27FC236}">
-                <a16:creationId xmlns:a16="http://schemas.microsoft.com/office/drawing/2014/main" id="{09A50E64-73D8-4B65-B631-2F4435C4E3B1}"/>
+                <a16:creationId xmlns:a16="http://schemas.microsoft.com/office/drawing/2014/main" id="{C0C0C7BF-D865-4F2F-9090-01C4E7EB41ED}"/>
               </a:ext>
             </a:extLst>
           </p:cNvPr>
@@ -13376,7 +13376,7 @@
           <p:cNvPr id="14" name="">
             <a:extLst xmlns:a="http://schemas.openxmlformats.org/drawingml/2006/main">
               <a:ext uri="{FF2B5EF4-FFF2-40B4-BE49-F238E27FC236}">
-                <a16:creationId xmlns:a16="http://schemas.microsoft.com/office/drawing/2014/main" id="{ADF05F35-4F8C-4783-B5CA-063A49C0818A}"/>
+                <a16:creationId xmlns:a16="http://schemas.microsoft.com/office/drawing/2014/main" id="{41FB2CFC-DA81-462A-8327-F9A2CC2A4BA7}"/>
               </a:ext>
             </a:extLst>
           </p:cNvPr>
@@ -13555,7 +13555,7 @@
           <p:cNvPr id="15" name="">
             <a:extLst xmlns:a="http://schemas.openxmlformats.org/drawingml/2006/main">
               <a:ext uri="{FF2B5EF4-FFF2-40B4-BE49-F238E27FC236}">
-                <a16:creationId xmlns:a16="http://schemas.microsoft.com/office/drawing/2014/main" id="{9C2ADF17-773B-44C7-A120-DC22C528BCA6}"/>
+                <a16:creationId xmlns:a16="http://schemas.microsoft.com/office/drawing/2014/main" id="{ED1063E5-9531-47EB-9197-0F8E3B729C9B}"/>
               </a:ext>
             </a:extLst>
           </p:cNvPr>
@@ -13587,7 +13587,7 @@
           <p:cNvPr id="16" name="">
             <a:extLst xmlns:a="http://schemas.openxmlformats.org/drawingml/2006/main">
               <a:ext uri="{FF2B5EF4-FFF2-40B4-BE49-F238E27FC236}">
-                <a16:creationId xmlns:a16="http://schemas.microsoft.com/office/drawing/2014/main" id="{32A82590-2E26-48A3-8442-711B78E2EE4C}"/>
+                <a16:creationId xmlns:a16="http://schemas.microsoft.com/office/drawing/2014/main" id="{EF2F0649-CDB8-4C77-9B7D-B0A4AAE9797D}"/>
               </a:ext>
             </a:extLst>
           </p:cNvPr>
@@ -13743,7 +13743,7 @@
           <p:cNvPr id="17" name="">
             <a:extLst xmlns:a="http://schemas.openxmlformats.org/drawingml/2006/main">
               <a:ext uri="{FF2B5EF4-FFF2-40B4-BE49-F238E27FC236}">
-                <a16:creationId xmlns:a16="http://schemas.microsoft.com/office/drawing/2014/main" id="{1E7F8A9B-44F8-4E5A-AC58-9CD4CAC48304}"/>
+                <a16:creationId xmlns:a16="http://schemas.microsoft.com/office/drawing/2014/main" id="{EB3B4512-0630-4C14-935C-9AC98E250BDC}"/>
               </a:ext>
             </a:extLst>
           </p:cNvPr>
@@ -13922,7 +13922,7 @@
           <p:cNvPr id="23" name="">
             <a:extLst xmlns:a="http://schemas.openxmlformats.org/drawingml/2006/main">
               <a:ext uri="{FF2B5EF4-FFF2-40B4-BE49-F238E27FC236}">
-                <a16:creationId xmlns:a16="http://schemas.microsoft.com/office/drawing/2014/main" id="{19C4CE6B-E11C-410A-A905-043D0D96DB0B}"/>
+                <a16:creationId xmlns:a16="http://schemas.microsoft.com/office/drawing/2014/main" id="{C3DA667B-A2E7-4631-A46B-0F2EF4A20F32}"/>
               </a:ext>
             </a:extLst>
           </p:cNvPr>
@@ -14101,7 +14101,7 @@
           <p:cNvPr id="24" name="">
             <a:extLst xmlns:a="http://schemas.openxmlformats.org/drawingml/2006/main">
               <a:ext uri="{FF2B5EF4-FFF2-40B4-BE49-F238E27FC236}">
-                <a16:creationId xmlns:a16="http://schemas.microsoft.com/office/drawing/2014/main" id="{2DAA92F1-0163-44FC-AE87-5A4F5515902B}"/>
+                <a16:creationId xmlns:a16="http://schemas.microsoft.com/office/drawing/2014/main" id="{BC0B53B0-4C19-48BB-9267-68C311D81968}"/>
               </a:ext>
             </a:extLst>
           </p:cNvPr>
@@ -14257,7 +14257,7 @@
           <p:cNvPr id="25" name="">
             <a:extLst xmlns:a="http://schemas.openxmlformats.org/drawingml/2006/main">
               <a:ext uri="{FF2B5EF4-FFF2-40B4-BE49-F238E27FC236}">
-                <a16:creationId xmlns:a16="http://schemas.microsoft.com/office/drawing/2014/main" id="{A113DF5A-0694-4479-94FE-84A07BD7908C}"/>
+                <a16:creationId xmlns:a16="http://schemas.microsoft.com/office/drawing/2014/main" id="{0F356C8D-A3E0-405F-B614-B977925B67EB}"/>
               </a:ext>
             </a:extLst>
           </p:cNvPr>
@@ -14413,7 +14413,7 @@
           <p:cNvPr id="26" name="">
             <a:extLst xmlns:a="http://schemas.openxmlformats.org/drawingml/2006/main">
               <a:ext uri="{FF2B5EF4-FFF2-40B4-BE49-F238E27FC236}">
-                <a16:creationId xmlns:a16="http://schemas.microsoft.com/office/drawing/2014/main" id="{30CC461E-4497-43E3-A982-51EAA442D4AC}"/>
+                <a16:creationId xmlns:a16="http://schemas.microsoft.com/office/drawing/2014/main" id="{A270C758-490B-44CD-A81E-764F4DF15880}"/>
               </a:ext>
             </a:extLst>
           </p:cNvPr>
@@ -14567,7 +14567,7 @@
     </p:spTree>
     <p:extLst>
       <p:ext uri="{BB962C8B-B14F-4D97-AF65-F5344CB8AC3E}">
-        <p14:creationId xmlns:p14="http://schemas.microsoft.com/office/powerpoint/2010/main" val="962620795"/>
+        <p14:creationId xmlns:p14="http://schemas.microsoft.com/office/powerpoint/2010/main" val="940222022"/>
       </p:ext>
     </p:extLst>
   </p:cSld>
@@ -14598,7 +14598,7 @@
           <p:cNvPr id="9" name="">
             <a:extLst xmlns:a="http://schemas.openxmlformats.org/drawingml/2006/main">
               <a:ext uri="{FF2B5EF4-FFF2-40B4-BE49-F238E27FC236}">
-                <a16:creationId xmlns:a16="http://schemas.microsoft.com/office/drawing/2014/main" id="{3A995F8C-5D2F-4A4D-8A2D-F739D15108C5}"/>
+                <a16:creationId xmlns:a16="http://schemas.microsoft.com/office/drawing/2014/main" id="{51F8B91C-FD48-46D1-9579-8D1B056E1B1A}"/>
               </a:ext>
             </a:extLst>
           </p:cNvPr>
@@ -14754,7 +14754,7 @@
           <p:cNvPr id="2" name="">
             <a:extLst xmlns:a="http://schemas.openxmlformats.org/drawingml/2006/main">
               <a:ext uri="{FF2B5EF4-FFF2-40B4-BE49-F238E27FC236}">
-                <a16:creationId xmlns:a16="http://schemas.microsoft.com/office/drawing/2014/main" id="{49A37297-4C5F-4C3E-AEB4-421E3B1699CF}"/>
+                <a16:creationId xmlns:a16="http://schemas.microsoft.com/office/drawing/2014/main" id="{A09FB159-16DD-4F2A-A403-95FCFA024965}"/>
               </a:ext>
             </a:extLst>
           </p:cNvPr>
@@ -14910,7 +14910,7 @@
           <p:cNvPr id="3" name="">
             <a:extLst xmlns:a="http://schemas.openxmlformats.org/drawingml/2006/main">
               <a:ext uri="{FF2B5EF4-FFF2-40B4-BE49-F238E27FC236}">
-                <a16:creationId xmlns:a16="http://schemas.microsoft.com/office/drawing/2014/main" id="{2C1F5459-D1A5-4573-92B7-8D805A527CD1}"/>
+                <a16:creationId xmlns:a16="http://schemas.microsoft.com/office/drawing/2014/main" id="{833A6446-5C20-45D8-9EE7-9A93AF39ECC4}"/>
               </a:ext>
             </a:extLst>
           </p:cNvPr>
@@ -15066,7 +15066,7 @@
           <p:cNvPr id="4" name="">
             <a:extLst xmlns:a="http://schemas.openxmlformats.org/drawingml/2006/main">
               <a:ext uri="{FF2B5EF4-FFF2-40B4-BE49-F238E27FC236}">
-                <a16:creationId xmlns:a16="http://schemas.microsoft.com/office/drawing/2014/main" id="{18F3D146-A9E9-47ED-8FCF-28A18795126F}"/>
+                <a16:creationId xmlns:a16="http://schemas.microsoft.com/office/drawing/2014/main" id="{6E129574-1657-4A69-B818-51D06E2D2F55}"/>
               </a:ext>
             </a:extLst>
           </p:cNvPr>
@@ -15222,7 +15222,7 @@
           <p:cNvPr id="5" name="">
             <a:extLst xmlns:a="http://schemas.openxmlformats.org/drawingml/2006/main">
               <a:ext uri="{FF2B5EF4-FFF2-40B4-BE49-F238E27FC236}">
-                <a16:creationId xmlns:a16="http://schemas.microsoft.com/office/drawing/2014/main" id="{F486C774-F9AB-4F51-9643-AAAB4619F94B}"/>
+                <a16:creationId xmlns:a16="http://schemas.microsoft.com/office/drawing/2014/main" id="{0827E4C3-C42B-4AFE-ADFA-EDF481022CF0}"/>
               </a:ext>
             </a:extLst>
           </p:cNvPr>
@@ -15378,7 +15378,7 @@
           <p:cNvPr id="6" name="">
             <a:extLst xmlns:a="http://schemas.openxmlformats.org/drawingml/2006/main">
               <a:ext uri="{FF2B5EF4-FFF2-40B4-BE49-F238E27FC236}">
-                <a16:creationId xmlns:a16="http://schemas.microsoft.com/office/drawing/2014/main" id="{152192B2-EC1E-4AAF-9014-38D02B61277F}"/>
+                <a16:creationId xmlns:a16="http://schemas.microsoft.com/office/drawing/2014/main" id="{C24F74E9-6D83-476D-9FCF-49597CB9B443}"/>
               </a:ext>
             </a:extLst>
           </p:cNvPr>
@@ -15534,7 +15534,7 @@
           <p:cNvPr id="7" name="">
             <a:extLst xmlns:a="http://schemas.openxmlformats.org/drawingml/2006/main">
               <a:ext uri="{FF2B5EF4-FFF2-40B4-BE49-F238E27FC236}">
-                <a16:creationId xmlns:a16="http://schemas.microsoft.com/office/drawing/2014/main" id="{C25AFBD3-6A18-4719-B998-4324E1743D3B}"/>
+                <a16:creationId xmlns:a16="http://schemas.microsoft.com/office/drawing/2014/main" id="{55FE2723-4967-46DC-80CB-B8DC5E6461E1}"/>
               </a:ext>
             </a:extLst>
           </p:cNvPr>
@@ -15544,7 +15544,7 @@
           <p:nvPr/>
         </p:nvPicPr>
         <p:blipFill>
-          <a:blip xmlns:r="http://schemas.openxmlformats.org/officeDocument/2006/relationships" xmlns:a="http://schemas.openxmlformats.org/drawingml/2006/main" r:embed="Red9c9216a20e46c5"/>
+          <a:blip xmlns:r="http://schemas.openxmlformats.org/officeDocument/2006/relationships" xmlns:a="http://schemas.openxmlformats.org/drawingml/2006/main" r:embed="R9a54397a908041cb"/>
           <a:stretch xmlns:a="http://schemas.openxmlformats.org/drawingml/2006/main"/>
         </p:blipFill>
         <p:spPr>
@@ -15562,7 +15562,7 @@
           <p:cNvPr id="8" name="">
             <a:extLst xmlns:a="http://schemas.openxmlformats.org/drawingml/2006/main">
               <a:ext uri="{FF2B5EF4-FFF2-40B4-BE49-F238E27FC236}">
-                <a16:creationId xmlns:a16="http://schemas.microsoft.com/office/drawing/2014/main" id="{7B0EDB78-97CB-4E80-86FC-FA62F8118708}"/>
+                <a16:creationId xmlns:a16="http://schemas.microsoft.com/office/drawing/2014/main" id="{6AF8EC10-A9D7-465F-BC94-DE5B5F41AD4F}"/>
               </a:ext>
             </a:extLst>
           </p:cNvPr>
@@ -15716,7 +15716,7 @@
     </p:spTree>
     <p:extLst>
       <p:ext uri="{BB962C8B-B14F-4D97-AF65-F5344CB8AC3E}">
-        <p14:creationId xmlns:p14="http://schemas.microsoft.com/office/powerpoint/2010/main" val="2131424082"/>
+        <p14:creationId xmlns:p14="http://schemas.microsoft.com/office/powerpoint/2010/main" val="971939569"/>
       </p:ext>
     </p:extLst>
   </p:cSld>
@@ -15747,7 +15747,7 @@
           <p:cNvPr id="9" name="">
             <a:extLst xmlns:a="http://schemas.openxmlformats.org/drawingml/2006/main">
               <a:ext uri="{FF2B5EF4-FFF2-40B4-BE49-F238E27FC236}">
-                <a16:creationId xmlns:a16="http://schemas.microsoft.com/office/drawing/2014/main" id="{180362F6-9794-4C73-9FD6-CA1979E55DC0}"/>
+                <a16:creationId xmlns:a16="http://schemas.microsoft.com/office/drawing/2014/main" id="{3FD2A0D0-2AF8-40DB-BAD6-CDEDE9738848}"/>
               </a:ext>
             </a:extLst>
           </p:cNvPr>
@@ -15903,7 +15903,7 @@
           <p:cNvPr id="2" name="">
             <a:extLst xmlns:a="http://schemas.openxmlformats.org/drawingml/2006/main">
               <a:ext uri="{FF2B5EF4-FFF2-40B4-BE49-F238E27FC236}">
-                <a16:creationId xmlns:a16="http://schemas.microsoft.com/office/drawing/2014/main" id="{C49DB157-FBA1-4DD9-A1E3-D86BC8D38102}"/>
+                <a16:creationId xmlns:a16="http://schemas.microsoft.com/office/drawing/2014/main" id="{F3F38A35-153E-4469-A4DA-639C717B7E0F}"/>
               </a:ext>
             </a:extLst>
           </p:cNvPr>
@@ -16059,7 +16059,7 @@
           <p:cNvPr id="3" name="">
             <a:extLst xmlns:a="http://schemas.openxmlformats.org/drawingml/2006/main">
               <a:ext uri="{FF2B5EF4-FFF2-40B4-BE49-F238E27FC236}">
-                <a16:creationId xmlns:a16="http://schemas.microsoft.com/office/drawing/2014/main" id="{AC73417E-A7FB-4C70-8EC4-DA619B583781}"/>
+                <a16:creationId xmlns:a16="http://schemas.microsoft.com/office/drawing/2014/main" id="{9FC0FD79-DC6A-41DF-B62F-82419F995AFC}"/>
               </a:ext>
             </a:extLst>
           </p:cNvPr>
@@ -16215,7 +16215,7 @@
           <p:cNvPr id="4" name="">
             <a:extLst xmlns:a="http://schemas.openxmlformats.org/drawingml/2006/main">
               <a:ext uri="{FF2B5EF4-FFF2-40B4-BE49-F238E27FC236}">
-                <a16:creationId xmlns:a16="http://schemas.microsoft.com/office/drawing/2014/main" id="{CC1CB7F7-9BA6-4457-BE3C-6ABAC209AA81}"/>
+                <a16:creationId xmlns:a16="http://schemas.microsoft.com/office/drawing/2014/main" id="{1A20B8B0-2A93-46F4-A89F-FB21505E4243}"/>
               </a:ext>
             </a:extLst>
           </p:cNvPr>
@@ -16371,7 +16371,7 @@
           <p:cNvPr id="5" name="">
             <a:extLst xmlns:a="http://schemas.openxmlformats.org/drawingml/2006/main">
               <a:ext uri="{FF2B5EF4-FFF2-40B4-BE49-F238E27FC236}">
-                <a16:creationId xmlns:a16="http://schemas.microsoft.com/office/drawing/2014/main" id="{DAB59BEC-8149-456B-B7EA-5A3698C06877}"/>
+                <a16:creationId xmlns:a16="http://schemas.microsoft.com/office/drawing/2014/main" id="{0CDBDED5-768C-4008-86CC-2FF785444185}"/>
               </a:ext>
             </a:extLst>
           </p:cNvPr>
@@ -16527,7 +16527,7 @@
           <p:cNvPr id="6" name="">
             <a:extLst xmlns:a="http://schemas.openxmlformats.org/drawingml/2006/main">
               <a:ext uri="{FF2B5EF4-FFF2-40B4-BE49-F238E27FC236}">
-                <a16:creationId xmlns:a16="http://schemas.microsoft.com/office/drawing/2014/main" id="{442160A2-5D02-4B93-A9D6-C8D356D5A013}"/>
+                <a16:creationId xmlns:a16="http://schemas.microsoft.com/office/drawing/2014/main" id="{21CD7DFA-CD4F-4E10-B92E-B2DD74896796}"/>
               </a:ext>
             </a:extLst>
           </p:cNvPr>
@@ -16683,7 +16683,7 @@
           <p:cNvPr id="7" name="">
             <a:extLst xmlns:a="http://schemas.openxmlformats.org/drawingml/2006/main">
               <a:ext uri="{FF2B5EF4-FFF2-40B4-BE49-F238E27FC236}">
-                <a16:creationId xmlns:a16="http://schemas.microsoft.com/office/drawing/2014/main" id="{418C2FDB-07D6-4AD4-8309-5CFCE46CEB6E}"/>
+                <a16:creationId xmlns:a16="http://schemas.microsoft.com/office/drawing/2014/main" id="{80E8E93A-427F-4898-93A9-28371B175F96}"/>
               </a:ext>
             </a:extLst>
           </p:cNvPr>
@@ -16693,7 +16693,7 @@
           <p:nvPr/>
         </p:nvPicPr>
         <p:blipFill>
-          <a:blip xmlns:r="http://schemas.openxmlformats.org/officeDocument/2006/relationships" xmlns:a="http://schemas.openxmlformats.org/drawingml/2006/main" r:embed="R9c4dd30408d34a63"/>
+          <a:blip xmlns:r="http://schemas.openxmlformats.org/officeDocument/2006/relationships" xmlns:a="http://schemas.openxmlformats.org/drawingml/2006/main" r:embed="R542ca5fdbc4c4d11"/>
           <a:stretch xmlns:a="http://schemas.openxmlformats.org/drawingml/2006/main"/>
         </p:blipFill>
         <p:spPr>
@@ -16711,7 +16711,7 @@
           <p:cNvPr id="8" name="">
             <a:extLst xmlns:a="http://schemas.openxmlformats.org/drawingml/2006/main">
               <a:ext uri="{FF2B5EF4-FFF2-40B4-BE49-F238E27FC236}">
-                <a16:creationId xmlns:a16="http://schemas.microsoft.com/office/drawing/2014/main" id="{73821629-3360-4329-9CAE-6945E1D859D6}"/>
+                <a16:creationId xmlns:a16="http://schemas.microsoft.com/office/drawing/2014/main" id="{2235323E-D81D-4EB3-9B0D-3FCA51C37FEF}"/>
               </a:ext>
             </a:extLst>
           </p:cNvPr>
@@ -16865,7 +16865,7 @@
     </p:spTree>
     <p:extLst>
       <p:ext uri="{BB962C8B-B14F-4D97-AF65-F5344CB8AC3E}">
-        <p14:creationId xmlns:p14="http://schemas.microsoft.com/office/powerpoint/2010/main" val="982639609"/>
+        <p14:creationId xmlns:p14="http://schemas.microsoft.com/office/powerpoint/2010/main" val="1388179110"/>
       </p:ext>
     </p:extLst>
   </p:cSld>
@@ -16896,7 +16896,7 @@
           <p:cNvPr id="10" name="">
             <a:extLst xmlns:a="http://schemas.openxmlformats.org/drawingml/2006/main">
               <a:ext uri="{FF2B5EF4-FFF2-40B4-BE49-F238E27FC236}">
-                <a16:creationId xmlns:a16="http://schemas.microsoft.com/office/drawing/2014/main" id="{6B17622C-038B-4CCF-8AB6-0D6C3FF9346D}"/>
+                <a16:creationId xmlns:a16="http://schemas.microsoft.com/office/drawing/2014/main" id="{63091E72-53F1-4F23-853D-FA35EF9A627A}"/>
               </a:ext>
             </a:extLst>
           </p:cNvPr>
@@ -17052,7 +17052,7 @@
           <p:cNvPr id="2" name="">
             <a:extLst xmlns:a="http://schemas.openxmlformats.org/drawingml/2006/main">
               <a:ext uri="{FF2B5EF4-FFF2-40B4-BE49-F238E27FC236}">
-                <a16:creationId xmlns:a16="http://schemas.microsoft.com/office/drawing/2014/main" id="{BF04D2DC-0C5F-4165-8059-FB72B921C057}"/>
+                <a16:creationId xmlns:a16="http://schemas.microsoft.com/office/drawing/2014/main" id="{FA832291-0216-41DE-B804-063FF2F77FBD}"/>
               </a:ext>
             </a:extLst>
           </p:cNvPr>
@@ -17208,7 +17208,7 @@
           <p:cNvPr id="3" name="">
             <a:extLst xmlns:a="http://schemas.openxmlformats.org/drawingml/2006/main">
               <a:ext uri="{FF2B5EF4-FFF2-40B4-BE49-F238E27FC236}">
-                <a16:creationId xmlns:a16="http://schemas.microsoft.com/office/drawing/2014/main" id="{639B909D-8F05-44BE-BC66-B425C0C3C92B}"/>
+                <a16:creationId xmlns:a16="http://schemas.microsoft.com/office/drawing/2014/main" id="{BCC33949-2F6C-4E96-90EF-D3D21AEF2913}"/>
               </a:ext>
             </a:extLst>
           </p:cNvPr>
@@ -17364,7 +17364,7 @@
           <p:cNvPr id="4" name="">
             <a:extLst xmlns:a="http://schemas.openxmlformats.org/drawingml/2006/main">
               <a:ext uri="{FF2B5EF4-FFF2-40B4-BE49-F238E27FC236}">
-                <a16:creationId xmlns:a16="http://schemas.microsoft.com/office/drawing/2014/main" id="{09CDD89F-3E0B-48AF-90D1-398DC02D217F}"/>
+                <a16:creationId xmlns:a16="http://schemas.microsoft.com/office/drawing/2014/main" id="{6A2E5135-121B-4980-9D1D-A9DEB661BBED}"/>
               </a:ext>
             </a:extLst>
           </p:cNvPr>
@@ -17520,7 +17520,7 @@
           <p:cNvPr id="5" name="">
             <a:extLst xmlns:a="http://schemas.openxmlformats.org/drawingml/2006/main">
               <a:ext uri="{FF2B5EF4-FFF2-40B4-BE49-F238E27FC236}">
-                <a16:creationId xmlns:a16="http://schemas.microsoft.com/office/drawing/2014/main" id="{A62014BB-E58F-4F64-80A0-79E04644799D}"/>
+                <a16:creationId xmlns:a16="http://schemas.microsoft.com/office/drawing/2014/main" id="{4C629CA2-7420-45F7-B822-539FB00F9DE9}"/>
               </a:ext>
             </a:extLst>
           </p:cNvPr>
@@ -17676,7 +17676,7 @@
           <p:cNvPr id="6" name="">
             <a:extLst xmlns:a="http://schemas.openxmlformats.org/drawingml/2006/main">
               <a:ext uri="{FF2B5EF4-FFF2-40B4-BE49-F238E27FC236}">
-                <a16:creationId xmlns:a16="http://schemas.microsoft.com/office/drawing/2014/main" id="{FE84D1DC-0209-44CF-9EDE-D93DD3936EFE}"/>
+                <a16:creationId xmlns:a16="http://schemas.microsoft.com/office/drawing/2014/main" id="{3E952A89-745F-49F9-87A5-1EE2F5F7EBB6}"/>
               </a:ext>
             </a:extLst>
           </p:cNvPr>
@@ -17832,7 +17832,7 @@
           <p:cNvPr id="7" name="">
             <a:extLst xmlns:a="http://schemas.openxmlformats.org/drawingml/2006/main">
               <a:ext uri="{FF2B5EF4-FFF2-40B4-BE49-F238E27FC236}">
-                <a16:creationId xmlns:a16="http://schemas.microsoft.com/office/drawing/2014/main" id="{6F6F7C1C-0470-413D-934C-A38BF29E562A}"/>
+                <a16:creationId xmlns:a16="http://schemas.microsoft.com/office/drawing/2014/main" id="{E4F8BFEE-89E2-4D2E-9461-1AC8FB733ECA}"/>
               </a:ext>
             </a:extLst>
           </p:cNvPr>
@@ -17842,7 +17842,7 @@
           <p:nvPr/>
         </p:nvPicPr>
         <p:blipFill>
-          <a:blip xmlns:r="http://schemas.openxmlformats.org/officeDocument/2006/relationships" xmlns:a="http://schemas.openxmlformats.org/drawingml/2006/main" r:embed="R0a8bdea5761a4f44"/>
+          <a:blip xmlns:r="http://schemas.openxmlformats.org/officeDocument/2006/relationships" xmlns:a="http://schemas.openxmlformats.org/drawingml/2006/main" r:embed="R4ef2127023d34a05"/>
           <a:stretch xmlns:a="http://schemas.openxmlformats.org/drawingml/2006/main"/>
         </p:blipFill>
         <p:spPr>
@@ -17860,7 +17860,7 @@
           <p:cNvPr id="8" name="">
             <a:extLst xmlns:a="http://schemas.openxmlformats.org/drawingml/2006/main">
               <a:ext uri="{FF2B5EF4-FFF2-40B4-BE49-F238E27FC236}">
-                <a16:creationId xmlns:a16="http://schemas.microsoft.com/office/drawing/2014/main" id="{39FE26A3-DCF8-41EB-98F9-D57FC459C7E8}"/>
+                <a16:creationId xmlns:a16="http://schemas.microsoft.com/office/drawing/2014/main" id="{4C6ED399-46F5-4C3F-86AA-B20F5CE78FD1}"/>
               </a:ext>
             </a:extLst>
           </p:cNvPr>
@@ -17870,7 +17870,7 @@
           <p:nvPr/>
         </p:nvPicPr>
         <p:blipFill>
-          <a:blip xmlns:r="http://schemas.openxmlformats.org/officeDocument/2006/relationships" xmlns:a="http://schemas.openxmlformats.org/drawingml/2006/main" r:embed="R0407cdcfd876490e"/>
+          <a:blip xmlns:r="http://schemas.openxmlformats.org/officeDocument/2006/relationships" xmlns:a="http://schemas.openxmlformats.org/drawingml/2006/main" r:embed="R6579e562395d4a0c"/>
           <a:stretch xmlns:a="http://schemas.openxmlformats.org/drawingml/2006/main"/>
         </p:blipFill>
         <p:spPr>
@@ -17888,7 +17888,7 @@
           <p:cNvPr id="9" name="">
             <a:extLst xmlns:a="http://schemas.openxmlformats.org/drawingml/2006/main">
               <a:ext uri="{FF2B5EF4-FFF2-40B4-BE49-F238E27FC236}">
-                <a16:creationId xmlns:a16="http://schemas.microsoft.com/office/drawing/2014/main" id="{7D083DE8-9737-4466-AC6F-86032169A3BA}"/>
+                <a16:creationId xmlns:a16="http://schemas.microsoft.com/office/drawing/2014/main" id="{7D1E1BBA-FEE3-4195-A94D-59D2EA7150E4}"/>
               </a:ext>
             </a:extLst>
           </p:cNvPr>
@@ -18042,7 +18042,7 @@
     </p:spTree>
     <p:extLst>
       <p:ext uri="{BB962C8B-B14F-4D97-AF65-F5344CB8AC3E}">
-        <p14:creationId xmlns:p14="http://schemas.microsoft.com/office/powerpoint/2010/main" val="218537873"/>
+        <p14:creationId xmlns:p14="http://schemas.microsoft.com/office/powerpoint/2010/main" val="150825415"/>
       </p:ext>
     </p:extLst>
   </p:cSld>
@@ -18073,7 +18073,7 @@
           <p:cNvPr id="9" name="">
             <a:extLst xmlns:a="http://schemas.openxmlformats.org/drawingml/2006/main">
               <a:ext uri="{FF2B5EF4-FFF2-40B4-BE49-F238E27FC236}">
-                <a16:creationId xmlns:a16="http://schemas.microsoft.com/office/drawing/2014/main" id="{53410CAC-C421-4702-ABA8-45DC8278F826}"/>
+                <a16:creationId xmlns:a16="http://schemas.microsoft.com/office/drawing/2014/main" id="{BF514B4F-C8CE-444F-B3A0-F8DD404CA572}"/>
               </a:ext>
             </a:extLst>
           </p:cNvPr>
@@ -18229,7 +18229,7 @@
           <p:cNvPr id="2" name="">
             <a:extLst xmlns:a="http://schemas.openxmlformats.org/drawingml/2006/main">
               <a:ext uri="{FF2B5EF4-FFF2-40B4-BE49-F238E27FC236}">
-                <a16:creationId xmlns:a16="http://schemas.microsoft.com/office/drawing/2014/main" id="{7DCBBF82-BF75-45EE-BAF8-1BE417D2FD72}"/>
+                <a16:creationId xmlns:a16="http://schemas.microsoft.com/office/drawing/2014/main" id="{26BC716E-6424-42B8-8489-1C2898D8A6CE}"/>
               </a:ext>
             </a:extLst>
           </p:cNvPr>
@@ -18385,7 +18385,7 @@
           <p:cNvPr id="3" name="">
             <a:extLst xmlns:a="http://schemas.openxmlformats.org/drawingml/2006/main">
               <a:ext uri="{FF2B5EF4-FFF2-40B4-BE49-F238E27FC236}">
-                <a16:creationId xmlns:a16="http://schemas.microsoft.com/office/drawing/2014/main" id="{0817167C-12DD-4B6C-A0BF-6BF6E40149B9}"/>
+                <a16:creationId xmlns:a16="http://schemas.microsoft.com/office/drawing/2014/main" id="{E8364014-8441-48B9-A56B-BB69DF28765F}"/>
               </a:ext>
             </a:extLst>
           </p:cNvPr>
@@ -18541,7 +18541,7 @@
           <p:cNvPr id="4" name="">
             <a:extLst xmlns:a="http://schemas.openxmlformats.org/drawingml/2006/main">
               <a:ext uri="{FF2B5EF4-FFF2-40B4-BE49-F238E27FC236}">
-                <a16:creationId xmlns:a16="http://schemas.microsoft.com/office/drawing/2014/main" id="{FE7C8DAC-3158-453E-92B1-4F7121BD2943}"/>
+                <a16:creationId xmlns:a16="http://schemas.microsoft.com/office/drawing/2014/main" id="{C9FDC2AE-4BFA-46D3-A7CA-7D97EE6350F2}"/>
               </a:ext>
             </a:extLst>
           </p:cNvPr>
@@ -18697,7 +18697,7 @@
           <p:cNvPr id="5" name="">
             <a:extLst xmlns:a="http://schemas.openxmlformats.org/drawingml/2006/main">
               <a:ext uri="{FF2B5EF4-FFF2-40B4-BE49-F238E27FC236}">
-                <a16:creationId xmlns:a16="http://schemas.microsoft.com/office/drawing/2014/main" id="{2CA5F075-7D73-46FB-9CDA-B8C58C1528C2}"/>
+                <a16:creationId xmlns:a16="http://schemas.microsoft.com/office/drawing/2014/main" id="{08E2F51B-BF68-4F34-91F6-260BA7CF206E}"/>
               </a:ext>
             </a:extLst>
           </p:cNvPr>
@@ -18853,7 +18853,7 @@
           <p:cNvPr id="6" name="">
             <a:extLst xmlns:a="http://schemas.openxmlformats.org/drawingml/2006/main">
               <a:ext uri="{FF2B5EF4-FFF2-40B4-BE49-F238E27FC236}">
-                <a16:creationId xmlns:a16="http://schemas.microsoft.com/office/drawing/2014/main" id="{64C58565-450B-4103-A5AE-672BBEBA579F}"/>
+                <a16:creationId xmlns:a16="http://schemas.microsoft.com/office/drawing/2014/main" id="{D3F5CB91-94D1-488A-979C-DC3E378B0B69}"/>
               </a:ext>
             </a:extLst>
           </p:cNvPr>
@@ -19009,7 +19009,7 @@
           <p:cNvPr id="7" name="">
             <a:extLst xmlns:a="http://schemas.openxmlformats.org/drawingml/2006/main">
               <a:ext uri="{FF2B5EF4-FFF2-40B4-BE49-F238E27FC236}">
-                <a16:creationId xmlns:a16="http://schemas.microsoft.com/office/drawing/2014/main" id="{38F3E49D-964D-4DFD-BF72-3999B26A6D1C}"/>
+                <a16:creationId xmlns:a16="http://schemas.microsoft.com/office/drawing/2014/main" id="{647A0F30-24B4-474C-B65A-322303AF7C99}"/>
               </a:ext>
             </a:extLst>
           </p:cNvPr>
@@ -19019,7 +19019,7 @@
           <p:nvPr/>
         </p:nvPicPr>
         <p:blipFill>
-          <a:blip xmlns:r="http://schemas.openxmlformats.org/officeDocument/2006/relationships" xmlns:a="http://schemas.openxmlformats.org/drawingml/2006/main" r:embed="R5e7f52fae9ff4728"/>
+          <a:blip xmlns:r="http://schemas.openxmlformats.org/officeDocument/2006/relationships" xmlns:a="http://schemas.openxmlformats.org/drawingml/2006/main" r:embed="Ra9993327bc264617"/>
           <a:stretch xmlns:a="http://schemas.openxmlformats.org/drawingml/2006/main"/>
         </p:blipFill>
         <p:spPr>
@@ -19037,7 +19037,7 @@
           <p:cNvPr id="8" name="">
             <a:extLst xmlns:a="http://schemas.openxmlformats.org/drawingml/2006/main">
               <a:ext uri="{FF2B5EF4-FFF2-40B4-BE49-F238E27FC236}">
-                <a16:creationId xmlns:a16="http://schemas.microsoft.com/office/drawing/2014/main" id="{B8F3CCFB-A496-4971-B017-591DBEE7578C}"/>
+                <a16:creationId xmlns:a16="http://schemas.microsoft.com/office/drawing/2014/main" id="{8752C122-FCC4-4F18-99C7-9739F9D5C6BB}"/>
               </a:ext>
             </a:extLst>
           </p:cNvPr>
@@ -19191,7 +19191,7 @@
     </p:spTree>
     <p:extLst>
       <p:ext uri="{BB962C8B-B14F-4D97-AF65-F5344CB8AC3E}">
-        <p14:creationId xmlns:p14="http://schemas.microsoft.com/office/powerpoint/2010/main" val="456912729"/>
+        <p14:creationId xmlns:p14="http://schemas.microsoft.com/office/powerpoint/2010/main" val="1999269209"/>
       </p:ext>
     </p:extLst>
   </p:cSld>
@@ -19222,7 +19222,7 @@
           <p:cNvPr id="5" name="">
             <a:extLst xmlns:a="http://schemas.openxmlformats.org/drawingml/2006/main">
               <a:ext uri="{FF2B5EF4-FFF2-40B4-BE49-F238E27FC236}">
-                <a16:creationId xmlns:a16="http://schemas.microsoft.com/office/drawing/2014/main" id="{592B2D07-E10A-4D42-870F-5889CCB02987}"/>
+                <a16:creationId xmlns:a16="http://schemas.microsoft.com/office/drawing/2014/main" id="{28B328A2-8177-48DE-B2BC-DBB292FB4A1C}"/>
               </a:ext>
             </a:extLst>
           </p:cNvPr>
@@ -19378,7 +19378,7 @@
           <p:cNvPr id="2" name="">
             <a:extLst xmlns:a="http://schemas.openxmlformats.org/drawingml/2006/main">
               <a:ext uri="{FF2B5EF4-FFF2-40B4-BE49-F238E27FC236}">
-                <a16:creationId xmlns:a16="http://schemas.microsoft.com/office/drawing/2014/main" id="{A3F45334-F6A6-4E41-838D-3F83B6853EC8}"/>
+                <a16:creationId xmlns:a16="http://schemas.microsoft.com/office/drawing/2014/main" id="{A63FF41B-30B2-43E9-969D-98436BE25451}"/>
               </a:ext>
             </a:extLst>
           </p:cNvPr>
@@ -19534,7 +19534,7 @@
           <p:cNvPr id="3" name="">
             <a:extLst xmlns:a="http://schemas.openxmlformats.org/drawingml/2006/main">
               <a:ext uri="{FF2B5EF4-FFF2-40B4-BE49-F238E27FC236}">
-                <a16:creationId xmlns:a16="http://schemas.microsoft.com/office/drawing/2014/main" id="{27354C3E-7D11-4186-9F43-A8A7BC1A7AA5}"/>
+                <a16:creationId xmlns:a16="http://schemas.microsoft.com/office/drawing/2014/main" id="{ED14B2FA-D498-4C76-9F24-98257C1D36CE}"/>
               </a:ext>
             </a:extLst>
           </p:cNvPr>
@@ -20054,7 +20054,7 @@
           <p:cNvPr id="4" name="">
             <a:extLst xmlns:a="http://schemas.openxmlformats.org/drawingml/2006/main">
               <a:ext uri="{FF2B5EF4-FFF2-40B4-BE49-F238E27FC236}">
-                <a16:creationId xmlns:a16="http://schemas.microsoft.com/office/drawing/2014/main" id="{BA5A6B2D-58C1-48CD-BF61-4963F6C76B94}"/>
+                <a16:creationId xmlns:a16="http://schemas.microsoft.com/office/drawing/2014/main" id="{4C699E62-EE7B-4802-ADED-FDECABA51D5A}"/>
               </a:ext>
             </a:extLst>
           </p:cNvPr>
@@ -20208,7 +20208,7 @@
     </p:spTree>
     <p:extLst>
       <p:ext uri="{BB962C8B-B14F-4D97-AF65-F5344CB8AC3E}">
-        <p14:creationId xmlns:p14="http://schemas.microsoft.com/office/powerpoint/2010/main" val="156907326"/>
+        <p14:creationId xmlns:p14="http://schemas.microsoft.com/office/powerpoint/2010/main" val="2142324479"/>
       </p:ext>
     </p:extLst>
   </p:cSld>

</xml_diff>